<commit_message>
Add Post-5G project map (memo + deck slide) and pilot-line linkage
Following METI 資料8-3 (NEDO Post-5G "B 先端半導体製造技術の開発",
2022-11-30 intermediate evaluation):

- research/POST5G_PROJECT_MAP.md: full project structure (B-a1 front-end
  GAA pilot line = TEL/SCREEN/Canon+AIST; B-b1/b2 back-end 3D packaging =
  TSMC 3DIC/RaaS/Sony; B-d1 = Rapidus 2nm; DISCO in B-b4 + AIST quantum
  line; budget ¥76.9B, 2030 ¥15T goal), 2022 outcomes, and a mapping to
  the repo's 12 demos.
- SEMICON_PILOT_LINE_GAA_PROCESS.md: add a "事業上の位置づけ (Post-5G B)"
  section linking the pilot-line tool list to B-a1.
- slides deck: +1 slide "Post-5G 'B' national project ↔ our demos"
  (now 18 slides); fix page-number footers (a prior sed had scrambled
  them) so 1–18 run in order; regenerate + sync generator.

Deck validated (schema PASS), content + footers checked via markitdown.

Co-Authored-By: Claude Opus 4.8 <noreply@anthropic.com>
Claude-Session: https://claude.ai/code/session_01TbPwqgUS5oNeMha35iGnea
</commit_message>
<xml_diff>
--- a/slides/weakform_operator_learning_semiconductor.pptx
+++ b/slides/weakform_operator_learning_semiconductor.pptx
@@ -22,9 +22,10 @@
     <p:sldId id="270" r:id="rId16"/>
     <p:sldId id="271" r:id="rId17"/>
     <p:sldId id="272" r:id="rId18"/>
+    <p:sldId id="273" r:id="rId19"/>
   </p:sldIdLst>
   <p:notesMasterIdLst>
-    <p:notesMasterId r:id="rId19"/>
+    <p:notesMasterId r:id="rId20"/>
   </p:notesMasterIdLst>
   <p:sldSz cx="12192000" cy="6858000"/>
   <p:notesSz cx="6858000" cy="12192000"/>
@@ -1246,6 +1247,94 @@
             <a:fld id="{F7021451-1387-4CA6-816F-3879F97B5CBC}" type="slidenum">
               <a:rPr lang="en-US"/>
               <a:t>17</a:t>
+            </a:fld>
+            <a:endParaRPr lang="en-US"/>
+          </a:p>
+        </p:txBody>
+      </p:sp>
+    </p:spTree>
+    <p:extLst>
+      <p:ext uri="{BB962C8B-B14F-4D97-AF65-F5344CB8AC3E}">
+        <p14:creationId xmlns:p14="http://schemas.microsoft.com/office/powerpoint/2010/main" val="1024086991"/>
+      </p:ext>
+    </p:extLst>
+  </p:cSld>
+  <p:clrMapOvr>
+    <a:masterClrMapping/>
+  </p:clrMapOvr>
+</p:notes>
+</file>
+
+<file path=ppt/notesSlides/notesSlide18.xml><?xml version="1.0" encoding="utf-8"?>
+<p:notes xmlns:a="http://schemas.openxmlformats.org/drawingml/2006/main" xmlns:r="http://schemas.openxmlformats.org/officeDocument/2006/relationships" xmlns:p="http://schemas.openxmlformats.org/presentationml/2006/main">
+  <p:cSld>
+    <p:spTree>
+      <p:nvGrpSpPr>
+        <p:cNvPr id="1" name=""/>
+        <p:cNvGrpSpPr/>
+        <p:nvPr/>
+      </p:nvGrpSpPr>
+      <p:grpSpPr>
+        <a:xfrm>
+          <a:off x="0" y="0"/>
+          <a:ext cx="0" cy="0"/>
+          <a:chOff x="0" y="0"/>
+          <a:chExt cx="0" cy="0"/>
+        </a:xfrm>
+      </p:grpSpPr>
+      <p:sp>
+        <p:nvSpPr>
+          <p:cNvPr id="2" name="Slide Image Placeholder 1"/>
+          <p:cNvSpPr>
+            <a:spLocks noGrp="1" noRot="1" noChangeAspect="1"/>
+          </p:cNvSpPr>
+          <p:nvPr>
+            <p:ph type="sldImg"/>
+          </p:nvPr>
+        </p:nvSpPr>
+        <p:spPr/>
+      </p:sp>
+      <p:sp>
+        <p:nvSpPr>
+          <p:cNvPr id="3" name="Notes Placeholder 2"/>
+          <p:cNvSpPr>
+            <a:spLocks noGrp="1"/>
+          </p:cNvSpPr>
+          <p:nvPr>
+            <p:ph type="body" idx="1"/>
+          </p:nvPr>
+        </p:nvSpPr>
+        <p:spPr/>
+        <p:txBody>
+          <a:bodyPr/>
+          <a:lstStyle/>
+          <a:p>
+            <a:r>
+              <a:rPr lang="en-US" dirty="0"/>
+              <a:t/>
+            </a:r>
+            <a:endParaRPr lang="en-US" dirty="0"/>
+          </a:p>
+        </p:txBody>
+      </p:sp>
+      <p:sp>
+        <p:nvSpPr>
+          <p:cNvPr id="4" name="Slide Number Placeholder 3"/>
+          <p:cNvSpPr>
+            <a:spLocks noGrp="1"/>
+          </p:cNvSpPr>
+          <p:nvPr>
+            <p:ph type="sldNum" sz="quarter" idx="10"/>
+          </p:nvPr>
+        </p:nvSpPr>
+        <p:spPr/>
+        <p:txBody>
+          <a:bodyPr/>
+          <a:lstStyle/>
+          <a:p>
+            <a:fld id="{F7021451-1387-4CA6-816F-3879F97B5CBC}" type="slidenum">
+              <a:rPr lang="en-US"/>
+              <a:t>18</a:t>
             </a:fld>
             <a:endParaRPr lang="en-US"/>
           </a:p>
@@ -6052,7 +6141,7 @@
                 <a:ea typeface="Calibri" pitchFamily="34" charset="-122"/>
                 <a:cs typeface="Calibri" pitchFamily="34" charset="-120"/>
               </a:rPr>
-              <a:t>16</a:t>
+              <a:t>14</a:t>
             </a:r>
             <a:endParaRPr lang="en-US" sz="1000" dirty="0"/>
           </a:p>
@@ -6110,13 +6199,13 @@
             <a:r>
               <a:rPr lang="en-US" sz="1300" b="1" spc="200" kern="0" dirty="0">
                 <a:solidFill>
-                  <a:srgbClr val="E9A13B"/>
-                </a:solidFill>
-                <a:latin typeface="Calibri" pitchFamily="34" charset="0"/>
-                <a:ea typeface="Calibri" pitchFamily="34" charset="-122"/>
-                <a:cs typeface="Calibri" pitchFamily="34" charset="-120"/>
-              </a:rPr>
-              <a:t>HONEST LIMITATIONS</a:t>
+                  <a:srgbClr val="1C9AA8"/>
+                </a:solidFill>
+                <a:latin typeface="Calibri" pitchFamily="34" charset="0"/>
+                <a:ea typeface="Calibri" pitchFamily="34" charset="-122"/>
+                <a:cs typeface="Calibri" pitchFamily="34" charset="-120"/>
+              </a:rPr>
+              <a:t>NATIONAL CONTEXT</a:t>
             </a:r>
             <a:endParaRPr lang="en-US" sz="1300" dirty="0"/>
           </a:p>
@@ -6155,7 +6244,7 @@
                 <a:ea typeface="Cambria" pitchFamily="34" charset="-122"/>
                 <a:cs typeface="Cambria" pitchFamily="34" charset="-120"/>
               </a:rPr>
-              <a:t>What is — and is not — demonstrated</a:t>
+              <a:t>Post-5G “B” national project ↔ our demos</a:t>
             </a:r>
             <a:endParaRPr lang="en-US" sz="3000" dirty="0"/>
           </a:p>
@@ -6163,34 +6252,113 @@
       </p:sp>
       <p:sp>
         <p:nvSpPr>
-          <p:cNvPr id="4" name="Text 2"/>
-          <p:cNvSpPr/>
-          <p:nvPr/>
-        </p:nvSpPr>
-        <p:spPr>
-          <a:xfrm>
-            <a:off x="640080" y="1783080"/>
-            <a:ext cx="10881360" cy="4206240"/>
-          </a:xfrm>
-          <a:prstGeom prst="rect">
-            <a:avLst/>
-          </a:prstGeom>
-          <a:noFill/>
-          <a:ln/>
-        </p:spPr>
-        <p:txBody>
-          <a:bodyPr wrap="square" lIns="0" tIns="0" rIns="0" bIns="0" rtlCol="0" anchor="t"/>
-          <a:lstStyle/>
-          <a:p>
-            <a:pPr marL="177800" indent="-177800">
-              <a:spcAft>
-                <a:spcPts val="800"/>
-              </a:spcAft>
-              <a:buSzPct val="100000"/>
-              <a:buChar char="•"/>
-            </a:pPr>
-            <a:r>
-              <a:rPr lang="en-US" sz="1550" dirty="0">
+          <p:cNvPr id="4" name="Shape 2"/>
+          <p:cNvSpPr/>
+          <p:nvPr/>
+        </p:nvSpPr>
+        <p:spPr>
+          <a:xfrm>
+            <a:off x="640080" y="1417320"/>
+            <a:ext cx="10881360" cy="502920"/>
+          </a:xfrm>
+          <a:prstGeom prst="roundRect">
+            <a:avLst>
+              <a:gd name="adj" fmla="val 14545"/>
+            </a:avLst>
+          </a:prstGeom>
+          <a:solidFill>
+            <a:srgbClr val="0B1F3A"/>
+          </a:solidFill>
+          <a:ln/>
+        </p:spPr>
+      </p:sp>
+      <p:sp>
+        <p:nvSpPr>
+          <p:cNvPr id="5" name="Text 3"/>
+          <p:cNvSpPr/>
+          <p:nvPr/>
+        </p:nvSpPr>
+        <p:spPr>
+          <a:xfrm>
+            <a:off x="868680" y="1417320"/>
+            <a:ext cx="10424160" cy="502920"/>
+          </a:xfrm>
+          <a:prstGeom prst="rect">
+            <a:avLst/>
+          </a:prstGeom>
+          <a:noFill/>
+          <a:ln/>
+        </p:spPr>
+        <p:txBody>
+          <a:bodyPr wrap="square" lIns="0" tIns="0" rIns="0" bIns="0" rtlCol="0" anchor="ctr"/>
+          <a:lstStyle/>
+          <a:p>
+            <a:pPr indent="0" marL="0">
+              <a:buNone/>
+            </a:pPr>
+            <a:r>
+              <a:rPr lang="en-US" sz="1250" b="1" dirty="0">
+                <a:solidFill>
+                  <a:srgbClr val="CADCFC"/>
+                </a:solidFill>
+                <a:latin typeface="Calibri" pitchFamily="34" charset="0"/>
+                <a:ea typeface="Calibri" pitchFamily="34" charset="-122"/>
+                <a:cs typeface="Calibri" pitchFamily="34" charset="-120"/>
+              </a:rPr>
+              <a:t>METI / NEDO Post-5G · 先端半導体製造技術 (B)    —    ¥76.9 B budget · target 2030: ¥15 T domestic semiconductor sales</a:t>
+            </a:r>
+            <a:endParaRPr lang="en-US" sz="1250" dirty="0"/>
+          </a:p>
+        </p:txBody>
+      </p:sp>
+      <p:sp>
+        <p:nvSpPr>
+          <p:cNvPr id="6" name="Shape 4"/>
+          <p:cNvSpPr/>
+          <p:nvPr/>
+        </p:nvSpPr>
+        <p:spPr>
+          <a:xfrm>
+            <a:off x="640080" y="2194560"/>
+            <a:ext cx="5669280" cy="914400"/>
+          </a:xfrm>
+          <a:prstGeom prst="roundRect">
+            <a:avLst>
+              <a:gd name="adj" fmla="val 7000"/>
+            </a:avLst>
+          </a:prstGeom>
+          <a:solidFill>
+            <a:srgbClr val="EEF3F8"/>
+          </a:solidFill>
+          <a:ln/>
+        </p:spPr>
+      </p:sp>
+      <p:sp>
+        <p:nvSpPr>
+          <p:cNvPr id="7" name="Text 5"/>
+          <p:cNvSpPr/>
+          <p:nvPr/>
+        </p:nvSpPr>
+        <p:spPr>
+          <a:xfrm>
+            <a:off x="822960" y="2194560"/>
+            <a:ext cx="5303520" cy="914400"/>
+          </a:xfrm>
+          <a:prstGeom prst="rect">
+            <a:avLst/>
+          </a:prstGeom>
+          <a:noFill/>
+          <a:ln/>
+        </p:spPr>
+        <p:txBody>
+          <a:bodyPr wrap="square" lIns="0" tIns="0" rIns="0" bIns="0" rtlCol="0" anchor="ctr"/>
+          <a:lstStyle/>
+          <a:p>
+            <a:pPr indent="0" marL="0">
+              <a:buNone/>
+            </a:pPr>
+            <a:r>
+              <a:rPr lang="en-US" sz="1300" b="1" dirty="0">
                 <a:solidFill>
                   <a:srgbClr val="1A2B45"/>
                 </a:solidFill>
@@ -6198,20 +6366,16 @@
                 <a:ea typeface="Calibri" pitchFamily="34" charset="-122"/>
                 <a:cs typeface="Calibri" pitchFamily="34" charset="-120"/>
               </a:rPr>
-              <a:t>All 11 are concept demos (CPU, minutes, seed-fixed).</a:t>
-            </a:r>
-            <a:endParaRPr lang="en-US" sz="1550" dirty="0"/>
-          </a:p>
-          <a:p>
-            <a:pPr marL="177800" indent="-177800">
-              <a:spcAft>
-                <a:spcPts val="800"/>
-              </a:spcAft>
-              <a:buSzPct val="100000"/>
-              <a:buChar char="•"/>
-            </a:pPr>
-            <a:r>
-              <a:rPr lang="en-US" sz="1550" dirty="0">
+              <a:t>B-a1 前工程 · GAA nanosheet</a:t>
+            </a:r>
+            <a:endParaRPr lang="en-US" sz="1300" dirty="0"/>
+          </a:p>
+          <a:p>
+            <a:pPr indent="0" marL="0">
+              <a:buNone/>
+            </a:pPr>
+            <a:r>
+              <a:rPr lang="en-US" sz="1300" b="1" dirty="0">
                 <a:solidFill>
                   <a:srgbClr val="1A2B45"/>
                 </a:solidFill>
@@ -6219,20 +6383,150 @@
                 <a:ea typeface="Calibri" pitchFamily="34" charset="-122"/>
                 <a:cs typeface="Calibri" pitchFamily="34" charset="-120"/>
               </a:rPr>
-              <a:t>①'s error indicator is the raw relative Galerkin residual; the tolerance is calibrated, not a solution-error bound.</a:t>
-            </a:r>
-            <a:endParaRPr lang="en-US" sz="1550" dirty="0"/>
-          </a:p>
-          <a:p>
-            <a:pPr marL="177800" indent="-177800">
-              <a:spcAft>
-                <a:spcPts val="800"/>
-              </a:spcAft>
-              <a:buSzPct val="100000"/>
-              <a:buChar char="•"/>
-            </a:pPr>
-            <a:r>
-              <a:rPr lang="en-US" sz="1550" dirty="0">
+              <a:t>TEL / SCREEN / Canon + AIST pilot line</a:t>
+            </a:r>
+            <a:endParaRPr lang="en-US" sz="1300" dirty="0"/>
+          </a:p>
+        </p:txBody>
+      </p:sp>
+      <p:sp>
+        <p:nvSpPr>
+          <p:cNvPr id="8" name="Shape 6"/>
+          <p:cNvSpPr/>
+          <p:nvPr/>
+        </p:nvSpPr>
+        <p:spPr>
+          <a:xfrm>
+            <a:off x="6355080" y="2651760"/>
+            <a:ext cx="914400" cy="914400"/>
+          </a:xfrm>
+          <a:prstGeom prst="line">
+            <a:avLst/>
+          </a:prstGeom>
+          <a:noFill/>
+          <a:ln w="31750">
+            <a:solidFill>
+              <a:srgbClr val="1C9AA8"/>
+            </a:solidFill>
+            <a:prstDash val="solid"/>
+            <a:tailEnd type="triangle"/>
+          </a:ln>
+        </p:spPr>
+      </p:sp>
+      <p:sp>
+        <p:nvSpPr>
+          <p:cNvPr id="9" name="Shape 7"/>
+          <p:cNvSpPr/>
+          <p:nvPr/>
+        </p:nvSpPr>
+        <p:spPr>
+          <a:xfrm>
+            <a:off x="6766560" y="2194560"/>
+            <a:ext cx="4480560" cy="914400"/>
+          </a:xfrm>
+          <a:prstGeom prst="roundRect">
+            <a:avLst>
+              <a:gd name="adj" fmla="val 7000"/>
+            </a:avLst>
+          </a:prstGeom>
+          <a:solidFill>
+            <a:srgbClr val="E7F0F7"/>
+          </a:solidFill>
+          <a:ln w="12700">
+            <a:solidFill>
+              <a:srgbClr val="1C9AA8"/>
+            </a:solidFill>
+            <a:prstDash val="solid"/>
+          </a:ln>
+        </p:spPr>
+      </p:sp>
+      <p:sp>
+        <p:nvSpPr>
+          <p:cNvPr id="10" name="Text 8"/>
+          <p:cNvSpPr/>
+          <p:nvPr/>
+        </p:nvSpPr>
+        <p:spPr>
+          <a:xfrm>
+            <a:off x="6949440" y="2194560"/>
+            <a:ext cx="4114800" cy="914400"/>
+          </a:xfrm>
+          <a:prstGeom prst="rect">
+            <a:avLst/>
+          </a:prstGeom>
+          <a:noFill/>
+          <a:ln/>
+        </p:spPr>
+        <p:txBody>
+          <a:bodyPr wrap="square" lIns="0" tIns="0" rIns="0" bIns="0" rtlCol="0" anchor="ctr"/>
+          <a:lstStyle/>
+          <a:p>
+            <a:pPr indent="0" marL="0">
+              <a:buNone/>
+            </a:pPr>
+            <a:r>
+              <a:rPr lang="en-US" sz="1300" dirty="0">
+                <a:solidFill>
+                  <a:srgbClr val="0E5A8A"/>
+                </a:solidFill>
+                <a:latin typeface="Calibri" pitchFamily="34" charset="0"/>
+                <a:ea typeface="Calibri" pitchFamily="34" charset="-122"/>
+                <a:cs typeface="Calibri" pitchFamily="34" charset="-120"/>
+              </a:rPr>
+              <a:t>GAA electrostatics  ①③④⑤⑩⑪⑫</a:t>
+            </a:r>
+            <a:endParaRPr lang="en-US" sz="1300" dirty="0"/>
+          </a:p>
+        </p:txBody>
+      </p:sp>
+      <p:sp>
+        <p:nvSpPr>
+          <p:cNvPr id="11" name="Shape 9"/>
+          <p:cNvSpPr/>
+          <p:nvPr/>
+        </p:nvSpPr>
+        <p:spPr>
+          <a:xfrm>
+            <a:off x="640080" y="3255264"/>
+            <a:ext cx="5669280" cy="914400"/>
+          </a:xfrm>
+          <a:prstGeom prst="roundRect">
+            <a:avLst>
+              <a:gd name="adj" fmla="val 7000"/>
+            </a:avLst>
+          </a:prstGeom>
+          <a:solidFill>
+            <a:srgbClr val="EEF3F8"/>
+          </a:solidFill>
+          <a:ln/>
+        </p:spPr>
+      </p:sp>
+      <p:sp>
+        <p:nvSpPr>
+          <p:cNvPr id="12" name="Text 10"/>
+          <p:cNvSpPr/>
+          <p:nvPr/>
+        </p:nvSpPr>
+        <p:spPr>
+          <a:xfrm>
+            <a:off x="822960" y="3255264"/>
+            <a:ext cx="5303520" cy="914400"/>
+          </a:xfrm>
+          <a:prstGeom prst="rect">
+            <a:avLst/>
+          </a:prstGeom>
+          <a:noFill/>
+          <a:ln/>
+        </p:spPr>
+        <p:txBody>
+          <a:bodyPr wrap="square" lIns="0" tIns="0" rIns="0" bIns="0" rtlCol="0" anchor="ctr"/>
+          <a:lstStyle/>
+          <a:p>
+            <a:pPr indent="0" marL="0">
+              <a:buNone/>
+            </a:pPr>
+            <a:r>
+              <a:rPr lang="en-US" sz="1300" b="1" dirty="0">
                 <a:solidFill>
                   <a:srgbClr val="1A2B45"/>
                 </a:solidFill>
@@ -6240,20 +6534,16 @@
                 <a:ea typeface="Calibri" pitchFamily="34" charset="-122"/>
                 <a:cs typeface="Calibri" pitchFamily="34" charset="-120"/>
               </a:rPr>
-              <a:t>Warm-start on robust monotone solves gives modest gains (~10–40%); the decisive case is ⑨ (converge vs diverge).</a:t>
-            </a:r>
-            <a:endParaRPr lang="en-US" sz="1550" dirty="0"/>
-          </a:p>
-          <a:p>
-            <a:pPr marL="177800" indent="-177800">
-              <a:spcAft>
-                <a:spcPts val="800"/>
-              </a:spcAft>
-              <a:buSzPct val="100000"/>
-              <a:buChar char="•"/>
-            </a:pPr>
-            <a:r>
-              <a:rPr lang="en-US" sz="1550" dirty="0">
+              <a:t>B-b1/b2 後工程 · 3D packaging · WoW/CoW</a:t>
+            </a:r>
+            <a:endParaRPr lang="en-US" sz="1300" dirty="0"/>
+          </a:p>
+          <a:p>
+            <a:pPr indent="0" marL="0">
+              <a:buNone/>
+            </a:pPr>
+            <a:r>
+              <a:rPr lang="en-US" sz="1300" b="1" dirty="0">
                 <a:solidFill>
                   <a:srgbClr val="1A2B45"/>
                 </a:solidFill>
@@ -6261,20 +6551,150 @@
                 <a:ea typeface="Calibri" pitchFamily="34" charset="-122"/>
                 <a:cs typeface="Calibri" pitchFamily="34" charset="-120"/>
               </a:rPr>
-              <a:t>1D full DD (⑧⑨) is implemented; coupled 2D/3D semiconductor DD (Full Newton, needs variable scaling) is future work.</a:t>
-            </a:r>
-            <a:endParaRPr lang="en-US" sz="1550" dirty="0"/>
-          </a:p>
-          <a:p>
-            <a:pPr marL="177800" indent="-177800">
-              <a:spcAft>
-                <a:spcPts val="800"/>
-              </a:spcAft>
-              <a:buSzPct val="100000"/>
-              <a:buChar char="•"/>
-            </a:pPr>
-            <a:r>
-              <a:rPr lang="en-US" sz="1550" dirty="0">
+              <a:t>TSMC 3DIC / RaaS / Sony</a:t>
+            </a:r>
+            <a:endParaRPr lang="en-US" sz="1300" dirty="0"/>
+          </a:p>
+        </p:txBody>
+      </p:sp>
+      <p:sp>
+        <p:nvSpPr>
+          <p:cNvPr id="13" name="Shape 11"/>
+          <p:cNvSpPr/>
+          <p:nvPr/>
+        </p:nvSpPr>
+        <p:spPr>
+          <a:xfrm>
+            <a:off x="6355080" y="3712464"/>
+            <a:ext cx="914400" cy="914400"/>
+          </a:xfrm>
+          <a:prstGeom prst="line">
+            <a:avLst/>
+          </a:prstGeom>
+          <a:noFill/>
+          <a:ln w="31750">
+            <a:solidFill>
+              <a:srgbClr val="1C9AA8"/>
+            </a:solidFill>
+            <a:prstDash val="solid"/>
+            <a:tailEnd type="triangle"/>
+          </a:ln>
+        </p:spPr>
+      </p:sp>
+      <p:sp>
+        <p:nvSpPr>
+          <p:cNvPr id="14" name="Shape 12"/>
+          <p:cNvSpPr/>
+          <p:nvPr/>
+        </p:nvSpPr>
+        <p:spPr>
+          <a:xfrm>
+            <a:off x="6766560" y="3255264"/>
+            <a:ext cx="4480560" cy="914400"/>
+          </a:xfrm>
+          <a:prstGeom prst="roundRect">
+            <a:avLst>
+              <a:gd name="adj" fmla="val 7000"/>
+            </a:avLst>
+          </a:prstGeom>
+          <a:solidFill>
+            <a:srgbClr val="E7F0F7"/>
+          </a:solidFill>
+          <a:ln w="12700">
+            <a:solidFill>
+              <a:srgbClr val="1C9AA8"/>
+            </a:solidFill>
+            <a:prstDash val="solid"/>
+          </a:ln>
+        </p:spPr>
+      </p:sp>
+      <p:sp>
+        <p:nvSpPr>
+          <p:cNvPr id="15" name="Text 13"/>
+          <p:cNvSpPr/>
+          <p:nvPr/>
+        </p:nvSpPr>
+        <p:spPr>
+          <a:xfrm>
+            <a:off x="6949440" y="3255264"/>
+            <a:ext cx="4114800" cy="914400"/>
+          </a:xfrm>
+          <a:prstGeom prst="rect">
+            <a:avLst/>
+          </a:prstGeom>
+          <a:noFill/>
+          <a:ln/>
+        </p:spPr>
+        <p:txBody>
+          <a:bodyPr wrap="square" lIns="0" tIns="0" rIns="0" bIns="0" rtlCol="0" anchor="ctr"/>
+          <a:lstStyle/>
+          <a:p>
+            <a:pPr indent="0" marL="0">
+              <a:buNone/>
+            </a:pPr>
+            <a:r>
+              <a:rPr lang="en-US" sz="1300" dirty="0">
+                <a:solidFill>
+                  <a:srgbClr val="0E5A8A"/>
+                </a:solidFill>
+                <a:latin typeface="Calibri" pitchFamily="34" charset="0"/>
+                <a:ea typeface="Calibri" pitchFamily="34" charset="-122"/>
+                <a:cs typeface="Calibri" pitchFamily="34" charset="-120"/>
+              </a:rPr>
+              <a:t>TSV thermo-mechanics  ⑥⑦  (+ CFRP×GNN)</a:t>
+            </a:r>
+            <a:endParaRPr lang="en-US" sz="1300" dirty="0"/>
+          </a:p>
+        </p:txBody>
+      </p:sp>
+      <p:sp>
+        <p:nvSpPr>
+          <p:cNvPr id="16" name="Shape 14"/>
+          <p:cNvSpPr/>
+          <p:nvPr/>
+        </p:nvSpPr>
+        <p:spPr>
+          <a:xfrm>
+            <a:off x="640080" y="4315968"/>
+            <a:ext cx="5669280" cy="914400"/>
+          </a:xfrm>
+          <a:prstGeom prst="roundRect">
+            <a:avLst>
+              <a:gd name="adj" fmla="val 7000"/>
+            </a:avLst>
+          </a:prstGeom>
+          <a:solidFill>
+            <a:srgbClr val="EEF3F8"/>
+          </a:solidFill>
+          <a:ln/>
+        </p:spPr>
+      </p:sp>
+      <p:sp>
+        <p:nvSpPr>
+          <p:cNvPr id="17" name="Text 15"/>
+          <p:cNvSpPr/>
+          <p:nvPr/>
+        </p:nvSpPr>
+        <p:spPr>
+          <a:xfrm>
+            <a:off x="822960" y="4315968"/>
+            <a:ext cx="5303520" cy="914400"/>
+          </a:xfrm>
+          <a:prstGeom prst="rect">
+            <a:avLst/>
+          </a:prstGeom>
+          <a:noFill/>
+          <a:ln/>
+        </p:spPr>
+        <p:txBody>
+          <a:bodyPr wrap="square" lIns="0" tIns="0" rIns="0" bIns="0" rtlCol="0" anchor="ctr"/>
+          <a:lstStyle/>
+          <a:p>
+            <a:pPr indent="0" marL="0">
+              <a:buNone/>
+            </a:pPr>
+            <a:r>
+              <a:rPr lang="en-US" sz="1300" b="1" dirty="0">
                 <a:solidFill>
                   <a:srgbClr val="1A2B45"/>
                 </a:solidFill>
@@ -6282,20 +6702,150 @@
                 <a:ea typeface="Calibri" pitchFamily="34" charset="-122"/>
                 <a:cs typeface="Calibri" pitchFamily="34" charset="-120"/>
               </a:rPr>
-              <a:t>"3D unimplemented" refers to semiconductor DD only — 3D thermoelasticity (⑦) is implemented.</a:t>
-            </a:r>
-            <a:endParaRPr lang="en-US" sz="1550" dirty="0"/>
-          </a:p>
-          <a:p>
-            <a:pPr marL="177800" indent="-177800">
-              <a:spcAft>
-                <a:spcPts val="800"/>
-              </a:spcAft>
-              <a:buSzPct val="100000"/>
-              <a:buChar char="•"/>
-            </a:pPr>
-            <a:r>
-              <a:rPr lang="en-US" sz="1550" dirty="0">
+              <a:t>new channel / interconnect · SiGe·Ge·2D, Cu→Ru</a:t>
+            </a:r>
+            <a:endParaRPr lang="en-US" sz="1300" dirty="0"/>
+          </a:p>
+        </p:txBody>
+      </p:sp>
+      <p:sp>
+        <p:nvSpPr>
+          <p:cNvPr id="18" name="Shape 16"/>
+          <p:cNvSpPr/>
+          <p:nvPr/>
+        </p:nvSpPr>
+        <p:spPr>
+          <a:xfrm>
+            <a:off x="6355080" y="4773168"/>
+            <a:ext cx="914400" cy="914400"/>
+          </a:xfrm>
+          <a:prstGeom prst="line">
+            <a:avLst/>
+          </a:prstGeom>
+          <a:noFill/>
+          <a:ln w="31750">
+            <a:solidFill>
+              <a:srgbClr val="1C9AA8"/>
+            </a:solidFill>
+            <a:prstDash val="solid"/>
+            <a:tailEnd type="triangle"/>
+          </a:ln>
+        </p:spPr>
+      </p:sp>
+      <p:sp>
+        <p:nvSpPr>
+          <p:cNvPr id="19" name="Shape 17"/>
+          <p:cNvSpPr/>
+          <p:nvPr/>
+        </p:nvSpPr>
+        <p:spPr>
+          <a:xfrm>
+            <a:off x="6766560" y="4315968"/>
+            <a:ext cx="4480560" cy="914400"/>
+          </a:xfrm>
+          <a:prstGeom prst="roundRect">
+            <a:avLst>
+              <a:gd name="adj" fmla="val 7000"/>
+            </a:avLst>
+          </a:prstGeom>
+          <a:solidFill>
+            <a:srgbClr val="E7F0F7"/>
+          </a:solidFill>
+          <a:ln w="12700">
+            <a:solidFill>
+              <a:srgbClr val="1C9AA8"/>
+            </a:solidFill>
+            <a:prstDash val="solid"/>
+          </a:ln>
+        </p:spPr>
+      </p:sp>
+      <p:sp>
+        <p:nvSpPr>
+          <p:cNvPr id="20" name="Text 18"/>
+          <p:cNvSpPr/>
+          <p:nvPr/>
+        </p:nvSpPr>
+        <p:spPr>
+          <a:xfrm>
+            <a:off x="6949440" y="4315968"/>
+            <a:ext cx="4114800" cy="914400"/>
+          </a:xfrm>
+          <a:prstGeom prst="rect">
+            <a:avLst/>
+          </a:prstGeom>
+          <a:noFill/>
+          <a:ln/>
+        </p:spPr>
+        <p:txBody>
+          <a:bodyPr wrap="square" lIns="0" tIns="0" rIns="0" bIns="0" rtlCol="0" anchor="ctr"/>
+          <a:lstStyle/>
+          <a:p>
+            <a:pPr indent="0" marL="0">
+              <a:buNone/>
+            </a:pPr>
+            <a:r>
+              <a:rPr lang="en-US" sz="1300" dirty="0">
+                <a:solidFill>
+                  <a:srgbClr val="0E5A8A"/>
+                </a:solidFill>
+                <a:latin typeface="Calibri" pitchFamily="34" charset="0"/>
+                <a:ea typeface="Calibri" pitchFamily="34" charset="-122"/>
+                <a:cs typeface="Calibri" pitchFamily="34" charset="-120"/>
+              </a:rPr>
+              <a:t>multi-material sweep  ⑩⑪  (Balaji+2026)</a:t>
+            </a:r>
+            <a:endParaRPr lang="en-US" sz="1300" dirty="0"/>
+          </a:p>
+        </p:txBody>
+      </p:sp>
+      <p:sp>
+        <p:nvSpPr>
+          <p:cNvPr id="21" name="Shape 19"/>
+          <p:cNvSpPr/>
+          <p:nvPr/>
+        </p:nvSpPr>
+        <p:spPr>
+          <a:xfrm>
+            <a:off x="640080" y="5376672"/>
+            <a:ext cx="5669280" cy="914400"/>
+          </a:xfrm>
+          <a:prstGeom prst="roundRect">
+            <a:avLst>
+              <a:gd name="adj" fmla="val 7000"/>
+            </a:avLst>
+          </a:prstGeom>
+          <a:solidFill>
+            <a:srgbClr val="EEF3F8"/>
+          </a:solidFill>
+          <a:ln/>
+        </p:spPr>
+      </p:sp>
+      <p:sp>
+        <p:nvSpPr>
+          <p:cNvPr id="22" name="Text 20"/>
+          <p:cNvSpPr/>
+          <p:nvPr/>
+        </p:nvSpPr>
+        <p:spPr>
+          <a:xfrm>
+            <a:off x="822960" y="5376672"/>
+            <a:ext cx="5303520" cy="914400"/>
+          </a:xfrm>
+          <a:prstGeom prst="rect">
+            <a:avLst/>
+          </a:prstGeom>
+          <a:noFill/>
+          <a:ln/>
+        </p:spPr>
+        <p:txBody>
+          <a:bodyPr wrap="square" lIns="0" tIns="0" rIns="0" bIns="0" rtlCol="0" anchor="ctr"/>
+          <a:lstStyle/>
+          <a:p>
+            <a:pPr indent="0" marL="0">
+              <a:buNone/>
+            </a:pPr>
+            <a:r>
+              <a:rPr lang="en-US" sz="1300" b="1" dirty="0">
                 <a:solidFill>
                   <a:srgbClr val="1A2B45"/>
                 </a:solidFill>
@@ -6303,15 +6853,105 @@
                 <a:ea typeface="Calibri" pitchFamily="34" charset="-122"/>
                 <a:cs typeface="Calibri" pitchFamily="34" charset="-120"/>
               </a:rPr>
-              <a:t>⑩⑪ screening κ is an illustrative non-dimensional scale (ordering &amp; trends are physical); ⑪'s disk is near radially symmetric.</a:t>
-            </a:r>
-            <a:endParaRPr lang="en-US" sz="1550" dirty="0"/>
-          </a:p>
-        </p:txBody>
-      </p:sp>
-      <p:sp>
-        <p:nvSpPr>
-          <p:cNvPr id="5" name="Text 3"/>
+              <a:t>B-d1 国際連携 · 2 nm logic (Rapidus)</a:t>
+            </a:r>
+            <a:endParaRPr lang="en-US" sz="1300" dirty="0"/>
+          </a:p>
+        </p:txBody>
+      </p:sp>
+      <p:sp>
+        <p:nvSpPr>
+          <p:cNvPr id="23" name="Shape 21"/>
+          <p:cNvSpPr/>
+          <p:nvPr/>
+        </p:nvSpPr>
+        <p:spPr>
+          <a:xfrm>
+            <a:off x="6355080" y="5833872"/>
+            <a:ext cx="914400" cy="914400"/>
+          </a:xfrm>
+          <a:prstGeom prst="line">
+            <a:avLst/>
+          </a:prstGeom>
+          <a:noFill/>
+          <a:ln w="31750">
+            <a:solidFill>
+              <a:srgbClr val="1C9AA8"/>
+            </a:solidFill>
+            <a:prstDash val="solid"/>
+            <a:tailEnd type="triangle"/>
+          </a:ln>
+        </p:spPr>
+      </p:sp>
+      <p:sp>
+        <p:nvSpPr>
+          <p:cNvPr id="24" name="Shape 22"/>
+          <p:cNvSpPr/>
+          <p:nvPr/>
+        </p:nvSpPr>
+        <p:spPr>
+          <a:xfrm>
+            <a:off x="6766560" y="5376672"/>
+            <a:ext cx="4480560" cy="914400"/>
+          </a:xfrm>
+          <a:prstGeom prst="roundRect">
+            <a:avLst>
+              <a:gd name="adj" fmla="val 7000"/>
+            </a:avLst>
+          </a:prstGeom>
+          <a:solidFill>
+            <a:srgbClr val="E7F0F7"/>
+          </a:solidFill>
+          <a:ln w="12700">
+            <a:solidFill>
+              <a:srgbClr val="1C9AA8"/>
+            </a:solidFill>
+            <a:prstDash val="solid"/>
+          </a:ln>
+        </p:spPr>
+      </p:sp>
+      <p:sp>
+        <p:nvSpPr>
+          <p:cNvPr id="25" name="Text 23"/>
+          <p:cNvSpPr/>
+          <p:nvPr/>
+        </p:nvSpPr>
+        <p:spPr>
+          <a:xfrm>
+            <a:off x="6949440" y="5376672"/>
+            <a:ext cx="4114800" cy="914400"/>
+          </a:xfrm>
+          <a:prstGeom prst="rect">
+            <a:avLst/>
+          </a:prstGeom>
+          <a:noFill/>
+          <a:ln/>
+        </p:spPr>
+        <p:txBody>
+          <a:bodyPr wrap="square" lIns="0" tIns="0" rIns="0" bIns="0" rtlCol="0" anchor="ctr"/>
+          <a:lstStyle/>
+          <a:p>
+            <a:pPr indent="0" marL="0">
+              <a:buNone/>
+            </a:pPr>
+            <a:r>
+              <a:rPr lang="en-US" sz="1300" dirty="0">
+                <a:solidFill>
+                  <a:srgbClr val="0E5A8A"/>
+                </a:solidFill>
+                <a:latin typeface="Calibri" pitchFamily="34" charset="0"/>
+                <a:ea typeface="Calibri" pitchFamily="34" charset="-122"/>
+                <a:cs typeface="Calibri" pitchFamily="34" charset="-120"/>
+              </a:rPr>
+              <a:t>the target device  (context)</a:t>
+            </a:r>
+            <a:endParaRPr lang="en-US" sz="1300" dirty="0"/>
+          </a:p>
+        </p:txBody>
+      </p:sp>
+      <p:sp>
+        <p:nvSpPr>
+          <p:cNvPr id="26" name="Text 24"/>
           <p:cNvSpPr/>
           <p:nvPr/>
         </p:nvSpPr>
@@ -6342,7 +6982,7 @@
                 <a:ea typeface="Calibri" pitchFamily="34" charset="-122"/>
                 <a:cs typeface="Calibri" pitchFamily="34" charset="-120"/>
               </a:rPr>
-              <a:t>17</a:t>
+              <a:t>15</a:t>
             </a:r>
             <a:endParaRPr lang="en-US" sz="1000" dirty="0"/>
           </a:p>
@@ -6400,13 +7040,13 @@
             <a:r>
               <a:rPr lang="en-US" sz="1300" b="1" spc="200" kern="0" dirty="0">
                 <a:solidFill>
-                  <a:srgbClr val="1C9AA8"/>
-                </a:solidFill>
-                <a:latin typeface="Calibri" pitchFamily="34" charset="0"/>
-                <a:ea typeface="Calibri" pitchFamily="34" charset="-122"/>
-                <a:cs typeface="Calibri" pitchFamily="34" charset="-120"/>
-              </a:rPr>
-              <a:t>ROADMAP</a:t>
+                  <a:srgbClr val="E9A13B"/>
+                </a:solidFill>
+                <a:latin typeface="Calibri" pitchFamily="34" charset="0"/>
+                <a:ea typeface="Calibri" pitchFamily="34" charset="-122"/>
+                <a:cs typeface="Calibri" pitchFamily="34" charset="-120"/>
+              </a:rPr>
+              <a:t>HONEST LIMITATIONS</a:t>
             </a:r>
             <a:endParaRPr lang="en-US" sz="1300" dirty="0"/>
           </a:p>
@@ -6445,7 +7085,7 @@
                 <a:ea typeface="Cambria" pitchFamily="34" charset="-122"/>
                 <a:cs typeface="Cambria" pitchFamily="34" charset="-120"/>
               </a:rPr>
-              <a:t>Next axes</a:t>
+              <a:t>What is — and is not — demonstrated</a:t>
             </a:r>
             <a:endParaRPr lang="en-US" sz="3000" dirty="0"/>
           </a:p>
@@ -6453,72 +7093,34 @@
       </p:sp>
       <p:sp>
         <p:nvSpPr>
-          <p:cNvPr id="4" name="Shape 2"/>
+          <p:cNvPr id="4" name="Text 2"/>
           <p:cNvSpPr/>
           <p:nvPr/>
         </p:nvSpPr>
         <p:spPr>
           <a:xfrm>
             <a:off x="640080" y="1783080"/>
-            <a:ext cx="10881360" cy="621792"/>
-          </a:xfrm>
-          <a:prstGeom prst="roundRect">
-            <a:avLst>
-              <a:gd name="adj" fmla="val 8824"/>
-            </a:avLst>
-          </a:prstGeom>
-          <a:solidFill>
-            <a:srgbClr val="EEF3F8"/>
-          </a:solidFill>
-          <a:ln/>
-        </p:spPr>
-      </p:sp>
-      <p:sp>
-        <p:nvSpPr>
-          <p:cNvPr id="5" name="Shape 3"/>
-          <p:cNvSpPr/>
-          <p:nvPr/>
-        </p:nvSpPr>
-        <p:spPr>
-          <a:xfrm>
-            <a:off x="822960" y="1956816"/>
-            <a:ext cx="274320" cy="274320"/>
-          </a:xfrm>
-          <a:prstGeom prst="ellipse">
-            <a:avLst/>
-          </a:prstGeom>
-          <a:solidFill>
-            <a:srgbClr val="1C9AA8"/>
-          </a:solidFill>
-          <a:ln/>
-        </p:spPr>
-      </p:sp>
-      <p:sp>
-        <p:nvSpPr>
-          <p:cNvPr id="6" name="Text 4"/>
-          <p:cNvSpPr/>
-          <p:nvPr/>
-        </p:nvSpPr>
-        <p:spPr>
-          <a:xfrm>
-            <a:off x="1280160" y="1783080"/>
-            <a:ext cx="9966960" cy="621792"/>
-          </a:xfrm>
-          <a:prstGeom prst="rect">
-            <a:avLst/>
-          </a:prstGeom>
-          <a:noFill/>
-          <a:ln/>
-        </p:spPr>
-        <p:txBody>
-          <a:bodyPr wrap="square" lIns="0" tIns="0" rIns="0" bIns="0" rtlCol="0" anchor="ctr"/>
-          <a:lstStyle/>
-          <a:p>
-            <a:pPr indent="0" marL="0">
-              <a:buNone/>
-            </a:pPr>
-            <a:r>
-              <a:rPr lang="en-US" sz="1500" dirty="0">
+            <a:ext cx="10881360" cy="4206240"/>
+          </a:xfrm>
+          <a:prstGeom prst="rect">
+            <a:avLst/>
+          </a:prstGeom>
+          <a:noFill/>
+          <a:ln/>
+        </p:spPr>
+        <p:txBody>
+          <a:bodyPr wrap="square" lIns="0" tIns="0" rIns="0" bIns="0" rtlCol="0" anchor="t"/>
+          <a:lstStyle/>
+          <a:p>
+            <a:pPr marL="177800" indent="-177800">
+              <a:spcAft>
+                <a:spcPts val="800"/>
+              </a:spcAft>
+              <a:buSzPct val="100000"/>
+              <a:buChar char="•"/>
+            </a:pPr>
+            <a:r>
+              <a:rPr lang="en-US" sz="1550" dirty="0">
                 <a:solidFill>
                   <a:srgbClr val="1A2B45"/>
                 </a:solidFill>
@@ -6526,80 +7128,20 @@
                 <a:ea typeface="Calibri" pitchFamily="34" charset="-122"/>
                 <a:cs typeface="Calibri" pitchFamily="34" charset="-120"/>
               </a:rPr>
-              <a:t>True vertical-gate geometry + unstructured mesh</a:t>
-            </a:r>
-            <a:endParaRPr lang="en-US" sz="1500" dirty="0"/>
-          </a:p>
-        </p:txBody>
-      </p:sp>
-      <p:sp>
-        <p:nvSpPr>
-          <p:cNvPr id="7" name="Shape 5"/>
-          <p:cNvSpPr/>
-          <p:nvPr/>
-        </p:nvSpPr>
-        <p:spPr>
-          <a:xfrm>
-            <a:off x="640080" y="2532888"/>
-            <a:ext cx="10881360" cy="621792"/>
-          </a:xfrm>
-          <a:prstGeom prst="roundRect">
-            <a:avLst>
-              <a:gd name="adj" fmla="val 8824"/>
-            </a:avLst>
-          </a:prstGeom>
-          <a:solidFill>
-            <a:srgbClr val="EEF3F8"/>
-          </a:solidFill>
-          <a:ln/>
-        </p:spPr>
-      </p:sp>
-      <p:sp>
-        <p:nvSpPr>
-          <p:cNvPr id="8" name="Shape 6"/>
-          <p:cNvSpPr/>
-          <p:nvPr/>
-        </p:nvSpPr>
-        <p:spPr>
-          <a:xfrm>
-            <a:off x="822960" y="2706624"/>
-            <a:ext cx="274320" cy="274320"/>
-          </a:xfrm>
-          <a:prstGeom prst="ellipse">
-            <a:avLst/>
-          </a:prstGeom>
-          <a:solidFill>
-            <a:srgbClr val="0E5A8A"/>
-          </a:solidFill>
-          <a:ln/>
-        </p:spPr>
-      </p:sp>
-      <p:sp>
-        <p:nvSpPr>
-          <p:cNvPr id="9" name="Text 7"/>
-          <p:cNvSpPr/>
-          <p:nvPr/>
-        </p:nvSpPr>
-        <p:spPr>
-          <a:xfrm>
-            <a:off x="1280160" y="2532888"/>
-            <a:ext cx="9966960" cy="621792"/>
-          </a:xfrm>
-          <a:prstGeom prst="rect">
-            <a:avLst/>
-          </a:prstGeom>
-          <a:noFill/>
-          <a:ln/>
-        </p:spPr>
-        <p:txBody>
-          <a:bodyPr wrap="square" lIns="0" tIns="0" rIns="0" bIns="0" rtlCol="0" anchor="ctr"/>
-          <a:lstStyle/>
-          <a:p>
-            <a:pPr indent="0" marL="0">
-              <a:buNone/>
-            </a:pPr>
-            <a:r>
-              <a:rPr lang="en-US" sz="1500" dirty="0">
+              <a:t>All 12 are concept demos (CPU, minutes, seed-fixed).</a:t>
+            </a:r>
+            <a:endParaRPr lang="en-US" sz="1550" dirty="0"/>
+          </a:p>
+          <a:p>
+            <a:pPr marL="177800" indent="-177800">
+              <a:spcAft>
+                <a:spcPts val="800"/>
+              </a:spcAft>
+              <a:buSzPct val="100000"/>
+              <a:buChar char="•"/>
+            </a:pPr>
+            <a:r>
+              <a:rPr lang="en-US" sz="1550" dirty="0">
                 <a:solidFill>
                   <a:srgbClr val="1A2B45"/>
                 </a:solidFill>
@@ -6607,80 +7149,20 @@
                 <a:ea typeface="Calibri" pitchFamily="34" charset="-122"/>
                 <a:cs typeface="Calibri" pitchFamily="34" charset="-120"/>
               </a:rPr>
-              <a:t>2D-CFET (2D-material channels)</a:t>
-            </a:r>
-            <a:endParaRPr lang="en-US" sz="1500" dirty="0"/>
-          </a:p>
-        </p:txBody>
-      </p:sp>
-      <p:sp>
-        <p:nvSpPr>
-          <p:cNvPr id="10" name="Shape 8"/>
-          <p:cNvSpPr/>
-          <p:nvPr/>
-        </p:nvSpPr>
-        <p:spPr>
-          <a:xfrm>
-            <a:off x="640080" y="3282696"/>
-            <a:ext cx="10881360" cy="621792"/>
-          </a:xfrm>
-          <a:prstGeom prst="roundRect">
-            <a:avLst>
-              <a:gd name="adj" fmla="val 8824"/>
-            </a:avLst>
-          </a:prstGeom>
-          <a:solidFill>
-            <a:srgbClr val="EEF3F8"/>
-          </a:solidFill>
-          <a:ln/>
-        </p:spPr>
-      </p:sp>
-      <p:sp>
-        <p:nvSpPr>
-          <p:cNvPr id="11" name="Shape 9"/>
-          <p:cNvSpPr/>
-          <p:nvPr/>
-        </p:nvSpPr>
-        <p:spPr>
-          <a:xfrm>
-            <a:off x="822960" y="3456432"/>
-            <a:ext cx="274320" cy="274320"/>
-          </a:xfrm>
-          <a:prstGeom prst="ellipse">
-            <a:avLst/>
-          </a:prstGeom>
-          <a:solidFill>
-            <a:srgbClr val="1C9AA8"/>
-          </a:solidFill>
-          <a:ln/>
-        </p:spPr>
-      </p:sp>
-      <p:sp>
-        <p:nvSpPr>
-          <p:cNvPr id="12" name="Text 10"/>
-          <p:cNvSpPr/>
-          <p:nvPr/>
-        </p:nvSpPr>
-        <p:spPr>
-          <a:xfrm>
-            <a:off x="1280160" y="3282696"/>
-            <a:ext cx="9966960" cy="621792"/>
-          </a:xfrm>
-          <a:prstGeom prst="rect">
-            <a:avLst/>
-          </a:prstGeom>
-          <a:noFill/>
-          <a:ln/>
-        </p:spPr>
-        <p:txBody>
-          <a:bodyPr wrap="square" lIns="0" tIns="0" rIns="0" bIns="0" rtlCol="0" anchor="ctr"/>
-          <a:lstStyle/>
-          <a:p>
-            <a:pPr indent="0" marL="0">
-              <a:buNone/>
-            </a:pPr>
-            <a:r>
-              <a:rPr lang="en-US" sz="1500" dirty="0">
+              <a:t>①'s error indicator is the raw relative Galerkin residual; the tolerance is calibrated, not a solution-error bound.</a:t>
+            </a:r>
+            <a:endParaRPr lang="en-US" sz="1550" dirty="0"/>
+          </a:p>
+          <a:p>
+            <a:pPr marL="177800" indent="-177800">
+              <a:spcAft>
+                <a:spcPts val="800"/>
+              </a:spcAft>
+              <a:buSzPct val="100000"/>
+              <a:buChar char="•"/>
+            </a:pPr>
+            <a:r>
+              <a:rPr lang="en-US" sz="1550" dirty="0">
                 <a:solidFill>
                   <a:srgbClr val="1A2B45"/>
                 </a:solidFill>
@@ -6688,80 +7170,20 @@
                 <a:ea typeface="Calibri" pitchFamily="34" charset="-122"/>
                 <a:cs typeface="Calibri" pitchFamily="34" charset="-120"/>
               </a:rPr>
-              <a:t>True avalanche (implicit G) &amp; 2D Full-Newton coupled DD (variable scaling)</a:t>
-            </a:r>
-            <a:endParaRPr lang="en-US" sz="1500" dirty="0"/>
-          </a:p>
-        </p:txBody>
-      </p:sp>
-      <p:sp>
-        <p:nvSpPr>
-          <p:cNvPr id="13" name="Shape 11"/>
-          <p:cNvSpPr/>
-          <p:nvPr/>
-        </p:nvSpPr>
-        <p:spPr>
-          <a:xfrm>
-            <a:off x="640080" y="4032504"/>
-            <a:ext cx="10881360" cy="621792"/>
-          </a:xfrm>
-          <a:prstGeom prst="roundRect">
-            <a:avLst>
-              <a:gd name="adj" fmla="val 8824"/>
-            </a:avLst>
-          </a:prstGeom>
-          <a:solidFill>
-            <a:srgbClr val="EEF3F8"/>
-          </a:solidFill>
-          <a:ln/>
-        </p:spPr>
-      </p:sp>
-      <p:sp>
-        <p:nvSpPr>
-          <p:cNvPr id="14" name="Shape 12"/>
-          <p:cNvSpPr/>
-          <p:nvPr/>
-        </p:nvSpPr>
-        <p:spPr>
-          <a:xfrm>
-            <a:off x="822960" y="4206240"/>
-            <a:ext cx="274320" cy="274320"/>
-          </a:xfrm>
-          <a:prstGeom prst="ellipse">
-            <a:avLst/>
-          </a:prstGeom>
-          <a:solidFill>
-            <a:srgbClr val="0E5A8A"/>
-          </a:solidFill>
-          <a:ln/>
-        </p:spPr>
-      </p:sp>
-      <p:sp>
-        <p:nvSpPr>
-          <p:cNvPr id="15" name="Text 13"/>
-          <p:cNvSpPr/>
-          <p:nvPr/>
-        </p:nvSpPr>
-        <p:spPr>
-          <a:xfrm>
-            <a:off x="1280160" y="4032504"/>
-            <a:ext cx="9966960" cy="621792"/>
-          </a:xfrm>
-          <a:prstGeom prst="rect">
-            <a:avLst/>
-          </a:prstGeom>
-          <a:noFill/>
-          <a:ln/>
-        </p:spPr>
-        <p:txBody>
-          <a:bodyPr wrap="square" lIns="0" tIns="0" rIns="0" bIns="0" rtlCol="0" anchor="ctr"/>
-          <a:lstStyle/>
-          <a:p>
-            <a:pPr indent="0" marL="0">
-              <a:buNone/>
-            </a:pPr>
-            <a:r>
-              <a:rPr lang="en-US" sz="1500" dirty="0">
+              <a:t>Warm-start on robust monotone solves gives modest gains (~10–40%); the decisive case is ⑨ (converge vs diverge).</a:t>
+            </a:r>
+            <a:endParaRPr lang="en-US" sz="1550" dirty="0"/>
+          </a:p>
+          <a:p>
+            <a:pPr marL="177800" indent="-177800">
+              <a:spcAft>
+                <a:spcPts val="800"/>
+              </a:spcAft>
+              <a:buSzPct val="100000"/>
+              <a:buChar char="•"/>
+            </a:pPr>
+            <a:r>
+              <a:rPr lang="en-US" sz="1550" dirty="0">
                 <a:solidFill>
                   <a:srgbClr val="1A2B45"/>
                 </a:solidFill>
@@ -6769,80 +7191,20 @@
                 <a:ea typeface="Calibri" pitchFamily="34" charset="-122"/>
                 <a:cs typeface="Calibri" pitchFamily="34" charset="-120"/>
               </a:rPr>
-              <a:t>Learned operator on asymmetric doping (trunk expressiveness) + GNN branch</a:t>
-            </a:r>
-            <a:endParaRPr lang="en-US" sz="1500" dirty="0"/>
-          </a:p>
-        </p:txBody>
-      </p:sp>
-      <p:sp>
-        <p:nvSpPr>
-          <p:cNvPr id="16" name="Shape 14"/>
-          <p:cNvSpPr/>
-          <p:nvPr/>
-        </p:nvSpPr>
-        <p:spPr>
-          <a:xfrm>
-            <a:off x="640080" y="4782312"/>
-            <a:ext cx="10881360" cy="621792"/>
-          </a:xfrm>
-          <a:prstGeom prst="roundRect">
-            <a:avLst>
-              <a:gd name="adj" fmla="val 8824"/>
-            </a:avLst>
-          </a:prstGeom>
-          <a:solidFill>
-            <a:srgbClr val="EEF3F8"/>
-          </a:solidFill>
-          <a:ln/>
-        </p:spPr>
-      </p:sp>
-      <p:sp>
-        <p:nvSpPr>
-          <p:cNvPr id="17" name="Shape 15"/>
-          <p:cNvSpPr/>
-          <p:nvPr/>
-        </p:nvSpPr>
-        <p:spPr>
-          <a:xfrm>
-            <a:off x="822960" y="4956048"/>
-            <a:ext cx="274320" cy="274320"/>
-          </a:xfrm>
-          <a:prstGeom prst="ellipse">
-            <a:avLst/>
-          </a:prstGeom>
-          <a:solidFill>
-            <a:srgbClr val="1C9AA8"/>
-          </a:solidFill>
-          <a:ln/>
-        </p:spPr>
-      </p:sp>
-      <p:sp>
-        <p:nvSpPr>
-          <p:cNvPr id="18" name="Text 16"/>
-          <p:cNvSpPr/>
-          <p:nvPr/>
-        </p:nvSpPr>
-        <p:spPr>
-          <a:xfrm>
-            <a:off x="1280160" y="4782312"/>
-            <a:ext cx="9966960" cy="621792"/>
-          </a:xfrm>
-          <a:prstGeom prst="rect">
-            <a:avLst/>
-          </a:prstGeom>
-          <a:noFill/>
-          <a:ln/>
-        </p:spPr>
-        <p:txBody>
-          <a:bodyPr wrap="square" lIns="0" tIns="0" rIns="0" bIns="0" rtlCol="0" anchor="ctr"/>
-          <a:lstStyle/>
-          <a:p>
-            <a:pPr indent="0" marL="0">
-              <a:buNone/>
-            </a:pPr>
-            <a:r>
-              <a:rPr lang="en-US" sz="1500" dirty="0">
+              <a:t>1D full DD (⑧⑨) is implemented; coupled 2D/3D semiconductor DD (Full Newton, needs variable scaling) is future work.</a:t>
+            </a:r>
+            <a:endParaRPr lang="en-US" sz="1550" dirty="0"/>
+          </a:p>
+          <a:p>
+            <a:pPr marL="177800" indent="-177800">
+              <a:spcAft>
+                <a:spcPts val="800"/>
+              </a:spcAft>
+              <a:buSzPct val="100000"/>
+              <a:buChar char="•"/>
+            </a:pPr>
+            <a:r>
+              <a:rPr lang="en-US" sz="1550" dirty="0">
                 <a:solidFill>
                   <a:srgbClr val="1A2B45"/>
                 </a:solidFill>
@@ -6850,80 +7212,20 @@
                 <a:ea typeface="Calibri" pitchFamily="34" charset="-122"/>
                 <a:cs typeface="Calibri" pitchFamily="34" charset="-120"/>
               </a:rPr>
-              <a:t>η-driven h-refinement (AMR) with mesh-agnostic branch</a:t>
-            </a:r>
-            <a:endParaRPr lang="en-US" sz="1500" dirty="0"/>
-          </a:p>
-        </p:txBody>
-      </p:sp>
-      <p:sp>
-        <p:nvSpPr>
-          <p:cNvPr id="19" name="Shape 17"/>
-          <p:cNvSpPr/>
-          <p:nvPr/>
-        </p:nvSpPr>
-        <p:spPr>
-          <a:xfrm>
-            <a:off x="640080" y="5532120"/>
-            <a:ext cx="10881360" cy="621792"/>
-          </a:xfrm>
-          <a:prstGeom prst="roundRect">
-            <a:avLst>
-              <a:gd name="adj" fmla="val 8824"/>
-            </a:avLst>
-          </a:prstGeom>
-          <a:solidFill>
-            <a:srgbClr val="EEF3F8"/>
-          </a:solidFill>
-          <a:ln/>
-        </p:spPr>
-      </p:sp>
-      <p:sp>
-        <p:nvSpPr>
-          <p:cNvPr id="20" name="Shape 18"/>
-          <p:cNvSpPr/>
-          <p:nvPr/>
-        </p:nvSpPr>
-        <p:spPr>
-          <a:xfrm>
-            <a:off x="822960" y="5705856"/>
-            <a:ext cx="274320" cy="274320"/>
-          </a:xfrm>
-          <a:prstGeom prst="ellipse">
-            <a:avLst/>
-          </a:prstGeom>
-          <a:solidFill>
-            <a:srgbClr val="0E5A8A"/>
-          </a:solidFill>
-          <a:ln/>
-        </p:spPr>
-      </p:sp>
-      <p:sp>
-        <p:nvSpPr>
-          <p:cNvPr id="21" name="Text 19"/>
-          <p:cNvSpPr/>
-          <p:nvPr/>
-        </p:nvSpPr>
-        <p:spPr>
-          <a:xfrm>
-            <a:off x="1280160" y="5532120"/>
-            <a:ext cx="9966960" cy="621792"/>
-          </a:xfrm>
-          <a:prstGeom prst="rect">
-            <a:avLst/>
-          </a:prstGeom>
-          <a:noFill/>
-          <a:ln/>
-        </p:spPr>
-        <p:txBody>
-          <a:bodyPr wrap="square" lIns="0" tIns="0" rIns="0" bIns="0" rtlCol="0" anchor="ctr"/>
-          <a:lstStyle/>
-          <a:p>
-            <a:pPr indent="0" marL="0">
-              <a:buNone/>
-            </a:pPr>
-            <a:r>
-              <a:rPr lang="en-US" sz="1500" dirty="0">
+              <a:t>"3D unimplemented" refers to semiconductor DD only — 3D thermoelasticity (⑦) is implemented.</a:t>
+            </a:r>
+            <a:endParaRPr lang="en-US" sz="1550" dirty="0"/>
+          </a:p>
+          <a:p>
+            <a:pPr marL="177800" indent="-177800">
+              <a:spcAft>
+                <a:spcPts val="800"/>
+              </a:spcAft>
+              <a:buSzPct val="100000"/>
+              <a:buChar char="•"/>
+            </a:pPr>
+            <a:r>
+              <a:rPr lang="en-US" sz="1550" dirty="0">
                 <a:solidFill>
                   <a:srgbClr val="1A2B45"/>
                 </a:solidFill>
@@ -6931,15 +7233,15 @@
                 <a:ea typeface="Calibri" pitchFamily="34" charset="-122"/>
                 <a:cs typeface="Calibri" pitchFamily="34" charset="-120"/>
               </a:rPr>
-              <a:t>3D stress-field surrogate; KOZ classification in the CFRP-defect GNN pipeline</a:t>
-            </a:r>
-            <a:endParaRPr lang="en-US" sz="1500" dirty="0"/>
-          </a:p>
-        </p:txBody>
-      </p:sp>
-      <p:sp>
-        <p:nvSpPr>
-          <p:cNvPr id="22" name="Text 20"/>
+              <a:t>⑩⑪ screening κ is an illustrative non-dimensional scale (ordering &amp; trends are physical); ⑪'s disk is near radially symmetric.</a:t>
+            </a:r>
+            <a:endParaRPr lang="en-US" sz="1550" dirty="0"/>
+          </a:p>
+        </p:txBody>
+      </p:sp>
+      <p:sp>
+        <p:nvSpPr>
+          <p:cNvPr id="5" name="Text 3"/>
           <p:cNvSpPr/>
           <p:nvPr/>
         </p:nvSpPr>
@@ -6987,6 +7289,634 @@
 <file path=ppt/slides/slide17.xml><?xml version="1.0" encoding="utf-8"?>
 <p:sld xmlns:a="http://schemas.openxmlformats.org/drawingml/2006/main" xmlns:r="http://schemas.openxmlformats.org/officeDocument/2006/relationships" xmlns:p="http://schemas.openxmlformats.org/presentationml/2006/main">
   <p:cSld name="Slide 17">
+    <p:spTree>
+      <p:nvGrpSpPr>
+        <p:cNvPr id="1" name=""/>
+        <p:cNvGrpSpPr/>
+        <p:nvPr/>
+      </p:nvGrpSpPr>
+      <p:grpSpPr>
+        <a:xfrm>
+          <a:off x="0" y="0"/>
+          <a:ext cx="0" cy="0"/>
+          <a:chOff x="0" y="0"/>
+          <a:chExt cx="0" cy="0"/>
+        </a:xfrm>
+      </p:grpSpPr>
+      <p:sp>
+        <p:nvSpPr>
+          <p:cNvPr id="2" name="Text 0"/>
+          <p:cNvSpPr/>
+          <p:nvPr/>
+        </p:nvSpPr>
+        <p:spPr>
+          <a:xfrm>
+            <a:off x="640080" y="457200"/>
+            <a:ext cx="10058400" cy="274320"/>
+          </a:xfrm>
+          <a:prstGeom prst="rect">
+            <a:avLst/>
+          </a:prstGeom>
+          <a:noFill/>
+          <a:ln/>
+        </p:spPr>
+        <p:txBody>
+          <a:bodyPr wrap="square" lIns="0" tIns="0" rIns="0" bIns="0" rtlCol="0" anchor="ctr"/>
+          <a:lstStyle/>
+          <a:p>
+            <a:pPr indent="0" marL="0">
+              <a:buNone/>
+            </a:pPr>
+            <a:r>
+              <a:rPr lang="en-US" sz="1300" b="1" spc="200" kern="0" dirty="0">
+                <a:solidFill>
+                  <a:srgbClr val="1C9AA8"/>
+                </a:solidFill>
+                <a:latin typeface="Calibri" pitchFamily="34" charset="0"/>
+                <a:ea typeface="Calibri" pitchFamily="34" charset="-122"/>
+                <a:cs typeface="Calibri" pitchFamily="34" charset="-120"/>
+              </a:rPr>
+              <a:t>ROADMAP</a:t>
+            </a:r>
+            <a:endParaRPr lang="en-US" sz="1300" dirty="0"/>
+          </a:p>
+        </p:txBody>
+      </p:sp>
+      <p:sp>
+        <p:nvSpPr>
+          <p:cNvPr id="3" name="Text 1"/>
+          <p:cNvSpPr/>
+          <p:nvPr/>
+        </p:nvSpPr>
+        <p:spPr>
+          <a:xfrm>
+            <a:off x="640080" y="731520"/>
+            <a:ext cx="10881360" cy="822960"/>
+          </a:xfrm>
+          <a:prstGeom prst="rect">
+            <a:avLst/>
+          </a:prstGeom>
+          <a:noFill/>
+          <a:ln/>
+        </p:spPr>
+        <p:txBody>
+          <a:bodyPr wrap="square" lIns="0" tIns="0" rIns="0" bIns="0" rtlCol="0" anchor="ctr"/>
+          <a:lstStyle/>
+          <a:p>
+            <a:pPr indent="0" marL="0">
+              <a:buNone/>
+            </a:pPr>
+            <a:r>
+              <a:rPr lang="en-US" sz="3000" b="1" dirty="0">
+                <a:solidFill>
+                  <a:srgbClr val="1A2B45"/>
+                </a:solidFill>
+                <a:latin typeface="Cambria" pitchFamily="34" charset="0"/>
+                <a:ea typeface="Cambria" pitchFamily="34" charset="-122"/>
+                <a:cs typeface="Cambria" pitchFamily="34" charset="-120"/>
+              </a:rPr>
+              <a:t>Next axes</a:t>
+            </a:r>
+            <a:endParaRPr lang="en-US" sz="3000" dirty="0"/>
+          </a:p>
+        </p:txBody>
+      </p:sp>
+      <p:sp>
+        <p:nvSpPr>
+          <p:cNvPr id="4" name="Shape 2"/>
+          <p:cNvSpPr/>
+          <p:nvPr/>
+        </p:nvSpPr>
+        <p:spPr>
+          <a:xfrm>
+            <a:off x="640080" y="1783080"/>
+            <a:ext cx="10881360" cy="621792"/>
+          </a:xfrm>
+          <a:prstGeom prst="roundRect">
+            <a:avLst>
+              <a:gd name="adj" fmla="val 8824"/>
+            </a:avLst>
+          </a:prstGeom>
+          <a:solidFill>
+            <a:srgbClr val="EEF3F8"/>
+          </a:solidFill>
+          <a:ln/>
+        </p:spPr>
+      </p:sp>
+      <p:sp>
+        <p:nvSpPr>
+          <p:cNvPr id="5" name="Shape 3"/>
+          <p:cNvSpPr/>
+          <p:nvPr/>
+        </p:nvSpPr>
+        <p:spPr>
+          <a:xfrm>
+            <a:off x="822960" y="1956816"/>
+            <a:ext cx="274320" cy="274320"/>
+          </a:xfrm>
+          <a:prstGeom prst="ellipse">
+            <a:avLst/>
+          </a:prstGeom>
+          <a:solidFill>
+            <a:srgbClr val="1C9AA8"/>
+          </a:solidFill>
+          <a:ln/>
+        </p:spPr>
+      </p:sp>
+      <p:sp>
+        <p:nvSpPr>
+          <p:cNvPr id="6" name="Text 4"/>
+          <p:cNvSpPr/>
+          <p:nvPr/>
+        </p:nvSpPr>
+        <p:spPr>
+          <a:xfrm>
+            <a:off x="1280160" y="1783080"/>
+            <a:ext cx="9966960" cy="621792"/>
+          </a:xfrm>
+          <a:prstGeom prst="rect">
+            <a:avLst/>
+          </a:prstGeom>
+          <a:noFill/>
+          <a:ln/>
+        </p:spPr>
+        <p:txBody>
+          <a:bodyPr wrap="square" lIns="0" tIns="0" rIns="0" bIns="0" rtlCol="0" anchor="ctr"/>
+          <a:lstStyle/>
+          <a:p>
+            <a:pPr indent="0" marL="0">
+              <a:buNone/>
+            </a:pPr>
+            <a:r>
+              <a:rPr lang="en-US" sz="1500" dirty="0">
+                <a:solidFill>
+                  <a:srgbClr val="1A2B45"/>
+                </a:solidFill>
+                <a:latin typeface="Calibri" pitchFamily="34" charset="0"/>
+                <a:ea typeface="Calibri" pitchFamily="34" charset="-122"/>
+                <a:cs typeface="Calibri" pitchFamily="34" charset="-120"/>
+              </a:rPr>
+              <a:t>True vertical-gate geometry + unstructured mesh</a:t>
+            </a:r>
+            <a:endParaRPr lang="en-US" sz="1500" dirty="0"/>
+          </a:p>
+        </p:txBody>
+      </p:sp>
+      <p:sp>
+        <p:nvSpPr>
+          <p:cNvPr id="7" name="Shape 5"/>
+          <p:cNvSpPr/>
+          <p:nvPr/>
+        </p:nvSpPr>
+        <p:spPr>
+          <a:xfrm>
+            <a:off x="640080" y="2532888"/>
+            <a:ext cx="10881360" cy="621792"/>
+          </a:xfrm>
+          <a:prstGeom prst="roundRect">
+            <a:avLst>
+              <a:gd name="adj" fmla="val 8824"/>
+            </a:avLst>
+          </a:prstGeom>
+          <a:solidFill>
+            <a:srgbClr val="EEF3F8"/>
+          </a:solidFill>
+          <a:ln/>
+        </p:spPr>
+      </p:sp>
+      <p:sp>
+        <p:nvSpPr>
+          <p:cNvPr id="8" name="Shape 6"/>
+          <p:cNvSpPr/>
+          <p:nvPr/>
+        </p:nvSpPr>
+        <p:spPr>
+          <a:xfrm>
+            <a:off x="822960" y="2706624"/>
+            <a:ext cx="274320" cy="274320"/>
+          </a:xfrm>
+          <a:prstGeom prst="ellipse">
+            <a:avLst/>
+          </a:prstGeom>
+          <a:solidFill>
+            <a:srgbClr val="0E5A8A"/>
+          </a:solidFill>
+          <a:ln/>
+        </p:spPr>
+      </p:sp>
+      <p:sp>
+        <p:nvSpPr>
+          <p:cNvPr id="9" name="Text 7"/>
+          <p:cNvSpPr/>
+          <p:nvPr/>
+        </p:nvSpPr>
+        <p:spPr>
+          <a:xfrm>
+            <a:off x="1280160" y="2532888"/>
+            <a:ext cx="9966960" cy="621792"/>
+          </a:xfrm>
+          <a:prstGeom prst="rect">
+            <a:avLst/>
+          </a:prstGeom>
+          <a:noFill/>
+          <a:ln/>
+        </p:spPr>
+        <p:txBody>
+          <a:bodyPr wrap="square" lIns="0" tIns="0" rIns="0" bIns="0" rtlCol="0" anchor="ctr"/>
+          <a:lstStyle/>
+          <a:p>
+            <a:pPr indent="0" marL="0">
+              <a:buNone/>
+            </a:pPr>
+            <a:r>
+              <a:rPr lang="en-US" sz="1500" dirty="0">
+                <a:solidFill>
+                  <a:srgbClr val="1A2B45"/>
+                </a:solidFill>
+                <a:latin typeface="Calibri" pitchFamily="34" charset="0"/>
+                <a:ea typeface="Calibri" pitchFamily="34" charset="-122"/>
+                <a:cs typeface="Calibri" pitchFamily="34" charset="-120"/>
+              </a:rPr>
+              <a:t>2D-CFET (2D-material channels)</a:t>
+            </a:r>
+            <a:endParaRPr lang="en-US" sz="1500" dirty="0"/>
+          </a:p>
+        </p:txBody>
+      </p:sp>
+      <p:sp>
+        <p:nvSpPr>
+          <p:cNvPr id="10" name="Shape 8"/>
+          <p:cNvSpPr/>
+          <p:nvPr/>
+        </p:nvSpPr>
+        <p:spPr>
+          <a:xfrm>
+            <a:off x="640080" y="3282696"/>
+            <a:ext cx="10881360" cy="621792"/>
+          </a:xfrm>
+          <a:prstGeom prst="roundRect">
+            <a:avLst>
+              <a:gd name="adj" fmla="val 8824"/>
+            </a:avLst>
+          </a:prstGeom>
+          <a:solidFill>
+            <a:srgbClr val="EEF3F8"/>
+          </a:solidFill>
+          <a:ln/>
+        </p:spPr>
+      </p:sp>
+      <p:sp>
+        <p:nvSpPr>
+          <p:cNvPr id="11" name="Shape 9"/>
+          <p:cNvSpPr/>
+          <p:nvPr/>
+        </p:nvSpPr>
+        <p:spPr>
+          <a:xfrm>
+            <a:off x="822960" y="3456432"/>
+            <a:ext cx="274320" cy="274320"/>
+          </a:xfrm>
+          <a:prstGeom prst="ellipse">
+            <a:avLst/>
+          </a:prstGeom>
+          <a:solidFill>
+            <a:srgbClr val="1C9AA8"/>
+          </a:solidFill>
+          <a:ln/>
+        </p:spPr>
+      </p:sp>
+      <p:sp>
+        <p:nvSpPr>
+          <p:cNvPr id="12" name="Text 10"/>
+          <p:cNvSpPr/>
+          <p:nvPr/>
+        </p:nvSpPr>
+        <p:spPr>
+          <a:xfrm>
+            <a:off x="1280160" y="3282696"/>
+            <a:ext cx="9966960" cy="621792"/>
+          </a:xfrm>
+          <a:prstGeom prst="rect">
+            <a:avLst/>
+          </a:prstGeom>
+          <a:noFill/>
+          <a:ln/>
+        </p:spPr>
+        <p:txBody>
+          <a:bodyPr wrap="square" lIns="0" tIns="0" rIns="0" bIns="0" rtlCol="0" anchor="ctr"/>
+          <a:lstStyle/>
+          <a:p>
+            <a:pPr indent="0" marL="0">
+              <a:buNone/>
+            </a:pPr>
+            <a:r>
+              <a:rPr lang="en-US" sz="1500" dirty="0">
+                <a:solidFill>
+                  <a:srgbClr val="1A2B45"/>
+                </a:solidFill>
+                <a:latin typeface="Calibri" pitchFamily="34" charset="0"/>
+                <a:ea typeface="Calibri" pitchFamily="34" charset="-122"/>
+                <a:cs typeface="Calibri" pitchFamily="34" charset="-120"/>
+              </a:rPr>
+              <a:t>True avalanche (implicit G) &amp; 2D Full-Newton coupled DD (variable scaling)</a:t>
+            </a:r>
+            <a:endParaRPr lang="en-US" sz="1500" dirty="0"/>
+          </a:p>
+        </p:txBody>
+      </p:sp>
+      <p:sp>
+        <p:nvSpPr>
+          <p:cNvPr id="13" name="Shape 11"/>
+          <p:cNvSpPr/>
+          <p:nvPr/>
+        </p:nvSpPr>
+        <p:spPr>
+          <a:xfrm>
+            <a:off x="640080" y="4032504"/>
+            <a:ext cx="10881360" cy="621792"/>
+          </a:xfrm>
+          <a:prstGeom prst="roundRect">
+            <a:avLst>
+              <a:gd name="adj" fmla="val 8824"/>
+            </a:avLst>
+          </a:prstGeom>
+          <a:solidFill>
+            <a:srgbClr val="EEF3F8"/>
+          </a:solidFill>
+          <a:ln/>
+        </p:spPr>
+      </p:sp>
+      <p:sp>
+        <p:nvSpPr>
+          <p:cNvPr id="14" name="Shape 12"/>
+          <p:cNvSpPr/>
+          <p:nvPr/>
+        </p:nvSpPr>
+        <p:spPr>
+          <a:xfrm>
+            <a:off x="822960" y="4206240"/>
+            <a:ext cx="274320" cy="274320"/>
+          </a:xfrm>
+          <a:prstGeom prst="ellipse">
+            <a:avLst/>
+          </a:prstGeom>
+          <a:solidFill>
+            <a:srgbClr val="0E5A8A"/>
+          </a:solidFill>
+          <a:ln/>
+        </p:spPr>
+      </p:sp>
+      <p:sp>
+        <p:nvSpPr>
+          <p:cNvPr id="15" name="Text 13"/>
+          <p:cNvSpPr/>
+          <p:nvPr/>
+        </p:nvSpPr>
+        <p:spPr>
+          <a:xfrm>
+            <a:off x="1280160" y="4032504"/>
+            <a:ext cx="9966960" cy="621792"/>
+          </a:xfrm>
+          <a:prstGeom prst="rect">
+            <a:avLst/>
+          </a:prstGeom>
+          <a:noFill/>
+          <a:ln/>
+        </p:spPr>
+        <p:txBody>
+          <a:bodyPr wrap="square" lIns="0" tIns="0" rIns="0" bIns="0" rtlCol="0" anchor="ctr"/>
+          <a:lstStyle/>
+          <a:p>
+            <a:pPr indent="0" marL="0">
+              <a:buNone/>
+            </a:pPr>
+            <a:r>
+              <a:rPr lang="en-US" sz="1500" dirty="0">
+                <a:solidFill>
+                  <a:srgbClr val="1A2B45"/>
+                </a:solidFill>
+                <a:latin typeface="Calibri" pitchFamily="34" charset="0"/>
+                <a:ea typeface="Calibri" pitchFamily="34" charset="-122"/>
+                <a:cs typeface="Calibri" pitchFamily="34" charset="-120"/>
+              </a:rPr>
+              <a:t>Learned operator on asymmetric doping (trunk expressiveness) + GNN branch</a:t>
+            </a:r>
+            <a:endParaRPr lang="en-US" sz="1500" dirty="0"/>
+          </a:p>
+        </p:txBody>
+      </p:sp>
+      <p:sp>
+        <p:nvSpPr>
+          <p:cNvPr id="16" name="Shape 14"/>
+          <p:cNvSpPr/>
+          <p:nvPr/>
+        </p:nvSpPr>
+        <p:spPr>
+          <a:xfrm>
+            <a:off x="640080" y="4782312"/>
+            <a:ext cx="10881360" cy="621792"/>
+          </a:xfrm>
+          <a:prstGeom prst="roundRect">
+            <a:avLst>
+              <a:gd name="adj" fmla="val 8824"/>
+            </a:avLst>
+          </a:prstGeom>
+          <a:solidFill>
+            <a:srgbClr val="EEF3F8"/>
+          </a:solidFill>
+          <a:ln/>
+        </p:spPr>
+      </p:sp>
+      <p:sp>
+        <p:nvSpPr>
+          <p:cNvPr id="17" name="Shape 15"/>
+          <p:cNvSpPr/>
+          <p:nvPr/>
+        </p:nvSpPr>
+        <p:spPr>
+          <a:xfrm>
+            <a:off x="822960" y="4956048"/>
+            <a:ext cx="274320" cy="274320"/>
+          </a:xfrm>
+          <a:prstGeom prst="ellipse">
+            <a:avLst/>
+          </a:prstGeom>
+          <a:solidFill>
+            <a:srgbClr val="1C9AA8"/>
+          </a:solidFill>
+          <a:ln/>
+        </p:spPr>
+      </p:sp>
+      <p:sp>
+        <p:nvSpPr>
+          <p:cNvPr id="18" name="Text 16"/>
+          <p:cNvSpPr/>
+          <p:nvPr/>
+        </p:nvSpPr>
+        <p:spPr>
+          <a:xfrm>
+            <a:off x="1280160" y="4782312"/>
+            <a:ext cx="9966960" cy="621792"/>
+          </a:xfrm>
+          <a:prstGeom prst="rect">
+            <a:avLst/>
+          </a:prstGeom>
+          <a:noFill/>
+          <a:ln/>
+        </p:spPr>
+        <p:txBody>
+          <a:bodyPr wrap="square" lIns="0" tIns="0" rIns="0" bIns="0" rtlCol="0" anchor="ctr"/>
+          <a:lstStyle/>
+          <a:p>
+            <a:pPr indent="0" marL="0">
+              <a:buNone/>
+            </a:pPr>
+            <a:r>
+              <a:rPr lang="en-US" sz="1500" dirty="0">
+                <a:solidFill>
+                  <a:srgbClr val="1A2B45"/>
+                </a:solidFill>
+                <a:latin typeface="Calibri" pitchFamily="34" charset="0"/>
+                <a:ea typeface="Calibri" pitchFamily="34" charset="-122"/>
+                <a:cs typeface="Calibri" pitchFamily="34" charset="-120"/>
+              </a:rPr>
+              <a:t>η-driven h-refinement (AMR) with mesh-agnostic branch</a:t>
+            </a:r>
+            <a:endParaRPr lang="en-US" sz="1500" dirty="0"/>
+          </a:p>
+        </p:txBody>
+      </p:sp>
+      <p:sp>
+        <p:nvSpPr>
+          <p:cNvPr id="19" name="Shape 17"/>
+          <p:cNvSpPr/>
+          <p:nvPr/>
+        </p:nvSpPr>
+        <p:spPr>
+          <a:xfrm>
+            <a:off x="640080" y="5532120"/>
+            <a:ext cx="10881360" cy="621792"/>
+          </a:xfrm>
+          <a:prstGeom prst="roundRect">
+            <a:avLst>
+              <a:gd name="adj" fmla="val 8824"/>
+            </a:avLst>
+          </a:prstGeom>
+          <a:solidFill>
+            <a:srgbClr val="EEF3F8"/>
+          </a:solidFill>
+          <a:ln/>
+        </p:spPr>
+      </p:sp>
+      <p:sp>
+        <p:nvSpPr>
+          <p:cNvPr id="20" name="Shape 18"/>
+          <p:cNvSpPr/>
+          <p:nvPr/>
+        </p:nvSpPr>
+        <p:spPr>
+          <a:xfrm>
+            <a:off x="822960" y="5705856"/>
+            <a:ext cx="274320" cy="274320"/>
+          </a:xfrm>
+          <a:prstGeom prst="ellipse">
+            <a:avLst/>
+          </a:prstGeom>
+          <a:solidFill>
+            <a:srgbClr val="0E5A8A"/>
+          </a:solidFill>
+          <a:ln/>
+        </p:spPr>
+      </p:sp>
+      <p:sp>
+        <p:nvSpPr>
+          <p:cNvPr id="21" name="Text 19"/>
+          <p:cNvSpPr/>
+          <p:nvPr/>
+        </p:nvSpPr>
+        <p:spPr>
+          <a:xfrm>
+            <a:off x="1280160" y="5532120"/>
+            <a:ext cx="9966960" cy="621792"/>
+          </a:xfrm>
+          <a:prstGeom prst="rect">
+            <a:avLst/>
+          </a:prstGeom>
+          <a:noFill/>
+          <a:ln/>
+        </p:spPr>
+        <p:txBody>
+          <a:bodyPr wrap="square" lIns="0" tIns="0" rIns="0" bIns="0" rtlCol="0" anchor="ctr"/>
+          <a:lstStyle/>
+          <a:p>
+            <a:pPr indent="0" marL="0">
+              <a:buNone/>
+            </a:pPr>
+            <a:r>
+              <a:rPr lang="en-US" sz="1500" dirty="0">
+                <a:solidFill>
+                  <a:srgbClr val="1A2B45"/>
+                </a:solidFill>
+                <a:latin typeface="Calibri" pitchFamily="34" charset="0"/>
+                <a:ea typeface="Calibri" pitchFamily="34" charset="-122"/>
+                <a:cs typeface="Calibri" pitchFamily="34" charset="-120"/>
+              </a:rPr>
+              <a:t>3D stress-field surrogate; KOZ classification in the CFRP-defect GNN pipeline</a:t>
+            </a:r>
+            <a:endParaRPr lang="en-US" sz="1500" dirty="0"/>
+          </a:p>
+        </p:txBody>
+      </p:sp>
+      <p:sp>
+        <p:nvSpPr>
+          <p:cNvPr id="22" name="Text 20"/>
+          <p:cNvSpPr/>
+          <p:nvPr/>
+        </p:nvSpPr>
+        <p:spPr>
+          <a:xfrm>
+            <a:off x="11548872" y="6446520"/>
+            <a:ext cx="457200" cy="274320"/>
+          </a:xfrm>
+          <a:prstGeom prst="rect">
+            <a:avLst/>
+          </a:prstGeom>
+          <a:noFill/>
+          <a:ln/>
+        </p:spPr>
+        <p:txBody>
+          <a:bodyPr wrap="square" rtlCol="0" anchor="ctr"/>
+          <a:lstStyle/>
+          <a:p>
+            <a:pPr algn="r" indent="0" marL="0">
+              <a:buNone/>
+            </a:pPr>
+            <a:r>
+              <a:rPr lang="en-US" sz="1000" dirty="0">
+                <a:solidFill>
+                  <a:srgbClr val="6B7A8F"/>
+                </a:solidFill>
+                <a:latin typeface="Calibri" pitchFamily="34" charset="0"/>
+                <a:ea typeface="Calibri" pitchFamily="34" charset="-122"/>
+                <a:cs typeface="Calibri" pitchFamily="34" charset="-120"/>
+              </a:rPr>
+              <a:t>17</a:t>
+            </a:r>
+            <a:endParaRPr lang="en-US" sz="1000" dirty="0"/>
+          </a:p>
+        </p:txBody>
+      </p:sp>
+    </p:spTree>
+  </p:cSld>
+  <p:clrMapOvr>
+    <a:masterClrMapping/>
+  </p:clrMapOvr>
+</p:sld>
+</file>
+
+<file path=ppt/slides/slide18.xml><?xml version="1.0" encoding="utf-8"?>
+<p:sld xmlns:a="http://schemas.openxmlformats.org/drawingml/2006/main" xmlns:r="http://schemas.openxmlformats.org/officeDocument/2006/relationships" xmlns:p="http://schemas.openxmlformats.org/presentationml/2006/main">
+  <p:cSld name="Slide 18">
     <p:bg>
       <p:bgPr>
         <a:solidFill>
@@ -7907,7 +8837,7 @@
                 <a:ea typeface="Calibri" pitchFamily="34" charset="-122"/>
                 <a:cs typeface="Calibri" pitchFamily="34" charset="-120"/>
               </a:rPr>
-              <a:t>17</a:t>
+              <a:t>18</a:t>
             </a:r>
             <a:endParaRPr lang="en-US" sz="1000" dirty="0"/>
           </a:p>

</xml_diff>

<commit_message>
Add national-R&D ecosystem memo + imec-vs-AIST/LSTC appendix slide
- research/SEMICON_NATIONAL_RD_ECOSYSTEM.md: operating-model comparison
  (imec IIAP / AIST-TIA / LSTC-Rapidus: membership, funding, IP, strengths),
  a Japan ecosystem mermaid map (NIMS→AIST/TIA→LSTC→Rapidus with equipment/
  material makers, universities, government), and an international pay note
  for national institutes. Figures approximate (flagged for verification).
- slides deck: +1 appendix slide (native comparison table imec vs
  産総研/TIA vs LSTC/Rapidus), now 19 slides; regenerate + sync generator.

Validated (schema PASS), content checked via markitdown.

Co-Authored-By: Claude Opus 4.8 <noreply@anthropic.com>
Claude-Session: https://claude.ai/code/session_01TbPwqgUS5oNeMha35iGnea
</commit_message>
<xml_diff>
--- a/slides/weakform_operator_learning_semiconductor.pptx
+++ b/slides/weakform_operator_learning_semiconductor.pptx
@@ -23,9 +23,10 @@
     <p:sldId id="271" r:id="rId17"/>
     <p:sldId id="272" r:id="rId18"/>
     <p:sldId id="273" r:id="rId19"/>
+    <p:sldId id="274" r:id="rId20"/>
   </p:sldIdLst>
   <p:notesMasterIdLst>
-    <p:notesMasterId r:id="rId20"/>
+    <p:notesMasterId r:id="rId21"/>
   </p:notesMasterIdLst>
   <p:sldSz cx="12192000" cy="6858000"/>
   <p:notesSz cx="6858000" cy="12192000"/>
@@ -1335,6 +1336,94 @@
             <a:fld id="{F7021451-1387-4CA6-816F-3879F97B5CBC}" type="slidenum">
               <a:rPr lang="en-US"/>
               <a:t>18</a:t>
+            </a:fld>
+            <a:endParaRPr lang="en-US"/>
+          </a:p>
+        </p:txBody>
+      </p:sp>
+    </p:spTree>
+    <p:extLst>
+      <p:ext uri="{BB962C8B-B14F-4D97-AF65-F5344CB8AC3E}">
+        <p14:creationId xmlns:p14="http://schemas.microsoft.com/office/powerpoint/2010/main" val="1024086991"/>
+      </p:ext>
+    </p:extLst>
+  </p:cSld>
+  <p:clrMapOvr>
+    <a:masterClrMapping/>
+  </p:clrMapOvr>
+</p:notes>
+</file>
+
+<file path=ppt/notesSlides/notesSlide19.xml><?xml version="1.0" encoding="utf-8"?>
+<p:notes xmlns:a="http://schemas.openxmlformats.org/drawingml/2006/main" xmlns:r="http://schemas.openxmlformats.org/officeDocument/2006/relationships" xmlns:p="http://schemas.openxmlformats.org/presentationml/2006/main">
+  <p:cSld>
+    <p:spTree>
+      <p:nvGrpSpPr>
+        <p:cNvPr id="1" name=""/>
+        <p:cNvGrpSpPr/>
+        <p:nvPr/>
+      </p:nvGrpSpPr>
+      <p:grpSpPr>
+        <a:xfrm>
+          <a:off x="0" y="0"/>
+          <a:ext cx="0" cy="0"/>
+          <a:chOff x="0" y="0"/>
+          <a:chExt cx="0" cy="0"/>
+        </a:xfrm>
+      </p:grpSpPr>
+      <p:sp>
+        <p:nvSpPr>
+          <p:cNvPr id="2" name="Slide Image Placeholder 1"/>
+          <p:cNvSpPr>
+            <a:spLocks noGrp="1" noRot="1" noChangeAspect="1"/>
+          </p:cNvSpPr>
+          <p:nvPr>
+            <p:ph type="sldImg"/>
+          </p:nvPr>
+        </p:nvSpPr>
+        <p:spPr/>
+      </p:sp>
+      <p:sp>
+        <p:nvSpPr>
+          <p:cNvPr id="3" name="Notes Placeholder 2"/>
+          <p:cNvSpPr>
+            <a:spLocks noGrp="1"/>
+          </p:cNvSpPr>
+          <p:nvPr>
+            <p:ph type="body" idx="1"/>
+          </p:nvPr>
+        </p:nvSpPr>
+        <p:spPr/>
+        <p:txBody>
+          <a:bodyPr/>
+          <a:lstStyle/>
+          <a:p>
+            <a:r>
+              <a:rPr lang="en-US" dirty="0"/>
+              <a:t/>
+            </a:r>
+            <a:endParaRPr lang="en-US" dirty="0"/>
+          </a:p>
+        </p:txBody>
+      </p:sp>
+      <p:sp>
+        <p:nvSpPr>
+          <p:cNvPr id="4" name="Slide Number Placeholder 3"/>
+          <p:cNvSpPr>
+            <a:spLocks noGrp="1"/>
+          </p:cNvSpPr>
+          <p:nvPr>
+            <p:ph type="sldNum" sz="quarter" idx="10"/>
+          </p:nvPr>
+        </p:nvSpPr>
+        <p:spPr/>
+        <p:txBody>
+          <a:bodyPr/>
+          <a:lstStyle/>
+          <a:p>
+            <a:fld id="{F7021451-1387-4CA6-816F-3879F97B5CBC}" type="slidenum">
+              <a:rPr lang="en-US"/>
+              <a:t>19</a:t>
             </a:fld>
             <a:endParaRPr lang="en-US"/>
           </a:p>
@@ -8851,6 +8940,1818 @@
 </p:sld>
 </file>
 
+<file path=ppt/slides/slide19.xml><?xml version="1.0" encoding="utf-8"?>
+<p:sld xmlns:a="http://schemas.openxmlformats.org/drawingml/2006/main" xmlns:r="http://schemas.openxmlformats.org/officeDocument/2006/relationships" xmlns:p="http://schemas.openxmlformats.org/presentationml/2006/main">
+  <p:cSld name="Slide 19">
+    <p:spTree>
+      <p:nvGrpSpPr>
+        <p:cNvPr id="1" name=""/>
+        <p:cNvGrpSpPr/>
+        <p:nvPr/>
+      </p:nvGrpSpPr>
+      <p:grpSpPr>
+        <a:xfrm>
+          <a:off x="0" y="0"/>
+          <a:ext cx="0" cy="0"/>
+          <a:chOff x="0" y="0"/>
+          <a:chExt cx="0" cy="0"/>
+        </a:xfrm>
+      </p:grpSpPr>
+      <p:sp>
+        <p:nvSpPr>
+          <p:cNvPr id="2" name="Text 0"/>
+          <p:cNvSpPr/>
+          <p:nvPr/>
+        </p:nvSpPr>
+        <p:spPr>
+          <a:xfrm>
+            <a:off x="640080" y="457200"/>
+            <a:ext cx="10058400" cy="274320"/>
+          </a:xfrm>
+          <a:prstGeom prst="rect">
+            <a:avLst/>
+          </a:prstGeom>
+          <a:noFill/>
+          <a:ln/>
+        </p:spPr>
+        <p:txBody>
+          <a:bodyPr wrap="square" lIns="0" tIns="0" rIns="0" bIns="0" rtlCol="0" anchor="ctr"/>
+          <a:lstStyle/>
+          <a:p>
+            <a:pPr indent="0" marL="0">
+              <a:buNone/>
+            </a:pPr>
+            <a:r>
+              <a:rPr lang="en-US" sz="1300" b="1" spc="200" kern="0" dirty="0">
+                <a:solidFill>
+                  <a:srgbClr val="1C9AA8"/>
+                </a:solidFill>
+                <a:latin typeface="Calibri" pitchFamily="34" charset="0"/>
+                <a:ea typeface="Calibri" pitchFamily="34" charset="-122"/>
+                <a:cs typeface="Calibri" pitchFamily="34" charset="-120"/>
+              </a:rPr>
+              <a:t>APPENDIX — INDUSTRY CONTEXT</a:t>
+            </a:r>
+            <a:endParaRPr lang="en-US" sz="1300" dirty="0"/>
+          </a:p>
+        </p:txBody>
+      </p:sp>
+      <p:sp>
+        <p:nvSpPr>
+          <p:cNvPr id="3" name="Text 1"/>
+          <p:cNvSpPr/>
+          <p:nvPr/>
+        </p:nvSpPr>
+        <p:spPr>
+          <a:xfrm>
+            <a:off x="640080" y="731520"/>
+            <a:ext cx="10881360" cy="822960"/>
+          </a:xfrm>
+          <a:prstGeom prst="rect">
+            <a:avLst/>
+          </a:prstGeom>
+          <a:noFill/>
+          <a:ln/>
+        </p:spPr>
+        <p:txBody>
+          <a:bodyPr wrap="square" lIns="0" tIns="0" rIns="0" bIns="0" rtlCol="0" anchor="ctr"/>
+          <a:lstStyle/>
+          <a:p>
+            <a:pPr indent="0" marL="0">
+              <a:buNone/>
+            </a:pPr>
+            <a:r>
+              <a:rPr lang="en-US" sz="3000" b="1" dirty="0">
+                <a:solidFill>
+                  <a:srgbClr val="1A2B45"/>
+                </a:solidFill>
+                <a:latin typeface="Cambria" pitchFamily="34" charset="0"/>
+                <a:ea typeface="Cambria" pitchFamily="34" charset="-122"/>
+                <a:cs typeface="Cambria" pitchFamily="34" charset="-120"/>
+              </a:rPr>
+              <a:t>Operating models: imec vs 産総研/TIA vs LSTC/Rapidus</a:t>
+            </a:r>
+            <a:endParaRPr lang="en-US" sz="3000" dirty="0"/>
+          </a:p>
+        </p:txBody>
+      </p:sp>
+      <p:graphicFrame>
+        <p:nvGraphicFramePr>
+          <p:cNvPr id="20" name="Table 0"/>
+          <p:cNvGraphicFramePr>
+            <a:graphicFrameLocks noGrp="1"/>
+          </p:cNvGraphicFramePr>
+          <p:nvPr>
+            <p:extLst>
+              <p:ext uri="{D42A27DB-BD31-4B8C-83A1-F6EECF244321}">
+                <p14:modId xmlns:p14="http://schemas.microsoft.com/office/powerpoint/2010/main" val="1579011935"/>
+              </p:ext>
+            </p:extLst>
+          </p:nvPr>
+        </p:nvGraphicFramePr>
+        <p:xfrm>
+          <a:off x="457200" y="1737360"/>
+          <a:ext cx="11247120" cy="914400"/>
+        </p:xfrm>
+        <a:graphic>
+          <a:graphicData uri="http://schemas.openxmlformats.org/drawingml/2006/table">
+            <a:tbl>
+              <a:tblPr/>
+              <a:tblGrid>
+                <a:gridCol w="1554480"/>
+                <a:gridCol w="3246120"/>
+                <a:gridCol w="3246120"/>
+                <a:gridCol w="3200400"/>
+              </a:tblGrid>
+              <a:tr h="566928">
+                <a:tc>
+                  <a:txBody>
+                    <a:bodyPr/>
+                    <a:lstStyle/>
+                    <a:p>
+                      <a:pPr algn="ctr" indent="0" marL="0">
+                        <a:buNone/>
+                      </a:pPr>
+                      <a:r>
+                        <a:rPr lang="en-US" sz="1150" b="1" dirty="0">
+                          <a:solidFill>
+                            <a:srgbClr val="FFFFFF"/>
+                          </a:solidFill>
+                          <a:latin typeface="Calibri" pitchFamily="34" charset="0"/>
+                          <a:ea typeface="Calibri" pitchFamily="34" charset="-122"/>
+                          <a:cs typeface="Calibri" pitchFamily="34" charset="-120"/>
+                        </a:rPr>
+                        <a:t>項目</a:t>
+                      </a:r>
+                      <a:endParaRPr lang="en-US" sz="1150" dirty="0">
+                        <a:latin typeface="Calibri" charset="0"/>
+                        <a:ea typeface="Calibri" charset="0"/>
+                        <a:cs typeface="Calibri" charset="0"/>
+                      </a:endParaRPr>
+                    </a:p>
+                  </a:txBody>
+                  <a:tcPr marL="63500" marR="63500" marT="63500" marB="63500" anchor="ctr">
+                    <a:lnL w="12700" cap="flat" cmpd="sng" algn="ctr">
+                      <a:solidFill>
+                        <a:srgbClr val="D6E0EA"/>
+                      </a:solidFill>
+                      <a:prstDash val="solid"/>
+                      <a:round/>
+                      <a:headEnd type="none" w="med" len="med"/>
+                      <a:tailEnd type="none" w="med" len="med"/>
+                    </a:lnL>
+                    <a:lnR w="12700" cap="flat" cmpd="sng" algn="ctr">
+                      <a:solidFill>
+                        <a:srgbClr val="D6E0EA"/>
+                      </a:solidFill>
+                      <a:prstDash val="solid"/>
+                      <a:round/>
+                      <a:headEnd type="none" w="med" len="med"/>
+                      <a:tailEnd type="none" w="med" len="med"/>
+                    </a:lnR>
+                    <a:lnT w="12700" cap="flat" cmpd="sng" algn="ctr">
+                      <a:solidFill>
+                        <a:srgbClr val="D6E0EA"/>
+                      </a:solidFill>
+                      <a:prstDash val="solid"/>
+                      <a:round/>
+                      <a:headEnd type="none" w="med" len="med"/>
+                      <a:tailEnd type="none" w="med" len="med"/>
+                    </a:lnT>
+                    <a:lnB w="12700" cap="flat" cmpd="sng" algn="ctr">
+                      <a:solidFill>
+                        <a:srgbClr val="D6E0EA"/>
+                      </a:solidFill>
+                      <a:prstDash val="solid"/>
+                      <a:round/>
+                      <a:headEnd type="none" w="med" len="med"/>
+                      <a:tailEnd type="none" w="med" len="med"/>
+                    </a:lnB>
+                    <a:solidFill>
+                      <a:srgbClr val="0B1F3A"/>
+                    </a:solidFill>
+                  </a:tcPr>
+                </a:tc>
+                <a:tc>
+                  <a:txBody>
+                    <a:bodyPr/>
+                    <a:lstStyle/>
+                    <a:p>
+                      <a:pPr algn="ctr" indent="0" marL="0">
+                        <a:buNone/>
+                      </a:pPr>
+                      <a:r>
+                        <a:rPr lang="en-US" sz="1150" b="1" dirty="0">
+                          <a:solidFill>
+                            <a:srgbClr val="FFFFFF"/>
+                          </a:solidFill>
+                          <a:latin typeface="Calibri" pitchFamily="34" charset="0"/>
+                          <a:ea typeface="Calibri" pitchFamily="34" charset="-122"/>
+                          <a:cs typeface="Calibri" pitchFamily="34" charset="-120"/>
+                        </a:rPr>
+                        <a:t>imec (BE)</a:t>
+                      </a:r>
+                      <a:endParaRPr lang="en-US" sz="1150" dirty="0">
+                        <a:latin typeface="Calibri" charset="0"/>
+                        <a:ea typeface="Calibri" charset="0"/>
+                        <a:cs typeface="Calibri" charset="0"/>
+                      </a:endParaRPr>
+                    </a:p>
+                  </a:txBody>
+                  <a:tcPr marL="63500" marR="63500" marT="63500" marB="63500" anchor="ctr">
+                    <a:lnL w="12700" cap="flat" cmpd="sng" algn="ctr">
+                      <a:solidFill>
+                        <a:srgbClr val="D6E0EA"/>
+                      </a:solidFill>
+                      <a:prstDash val="solid"/>
+                      <a:round/>
+                      <a:headEnd type="none" w="med" len="med"/>
+                      <a:tailEnd type="none" w="med" len="med"/>
+                    </a:lnL>
+                    <a:lnR w="12700" cap="flat" cmpd="sng" algn="ctr">
+                      <a:solidFill>
+                        <a:srgbClr val="D6E0EA"/>
+                      </a:solidFill>
+                      <a:prstDash val="solid"/>
+                      <a:round/>
+                      <a:headEnd type="none" w="med" len="med"/>
+                      <a:tailEnd type="none" w="med" len="med"/>
+                    </a:lnR>
+                    <a:lnT w="12700" cap="flat" cmpd="sng" algn="ctr">
+                      <a:solidFill>
+                        <a:srgbClr val="D6E0EA"/>
+                      </a:solidFill>
+                      <a:prstDash val="solid"/>
+                      <a:round/>
+                      <a:headEnd type="none" w="med" len="med"/>
+                      <a:tailEnd type="none" w="med" len="med"/>
+                    </a:lnT>
+                    <a:lnB w="12700" cap="flat" cmpd="sng" algn="ctr">
+                      <a:solidFill>
+                        <a:srgbClr val="D6E0EA"/>
+                      </a:solidFill>
+                      <a:prstDash val="solid"/>
+                      <a:round/>
+                      <a:headEnd type="none" w="med" len="med"/>
+                      <a:tailEnd type="none" w="med" len="med"/>
+                    </a:lnB>
+                    <a:solidFill>
+                      <a:srgbClr val="0B1F3A"/>
+                    </a:solidFill>
+                  </a:tcPr>
+                </a:tc>
+                <a:tc>
+                  <a:txBody>
+                    <a:bodyPr/>
+                    <a:lstStyle/>
+                    <a:p>
+                      <a:pPr algn="ctr" indent="0" marL="0">
+                        <a:buNone/>
+                      </a:pPr>
+                      <a:r>
+                        <a:rPr lang="en-US" sz="1150" b="1" dirty="0">
+                          <a:solidFill>
+                            <a:srgbClr val="FFFFFF"/>
+                          </a:solidFill>
+                          <a:latin typeface="Calibri" pitchFamily="34" charset="0"/>
+                          <a:ea typeface="Calibri" pitchFamily="34" charset="-122"/>
+                          <a:cs typeface="Calibri" pitchFamily="34" charset="-120"/>
+                        </a:rPr>
+                        <a:t>産総研 / TIA (JP)</a:t>
+                      </a:r>
+                      <a:endParaRPr lang="en-US" sz="1150" dirty="0">
+                        <a:latin typeface="Calibri" charset="0"/>
+                        <a:ea typeface="Calibri" charset="0"/>
+                        <a:cs typeface="Calibri" charset="0"/>
+                      </a:endParaRPr>
+                    </a:p>
+                  </a:txBody>
+                  <a:tcPr marL="63500" marR="63500" marT="63500" marB="63500" anchor="ctr">
+                    <a:lnL w="12700" cap="flat" cmpd="sng" algn="ctr">
+                      <a:solidFill>
+                        <a:srgbClr val="D6E0EA"/>
+                      </a:solidFill>
+                      <a:prstDash val="solid"/>
+                      <a:round/>
+                      <a:headEnd type="none" w="med" len="med"/>
+                      <a:tailEnd type="none" w="med" len="med"/>
+                    </a:lnL>
+                    <a:lnR w="12700" cap="flat" cmpd="sng" algn="ctr">
+                      <a:solidFill>
+                        <a:srgbClr val="D6E0EA"/>
+                      </a:solidFill>
+                      <a:prstDash val="solid"/>
+                      <a:round/>
+                      <a:headEnd type="none" w="med" len="med"/>
+                      <a:tailEnd type="none" w="med" len="med"/>
+                    </a:lnR>
+                    <a:lnT w="12700" cap="flat" cmpd="sng" algn="ctr">
+                      <a:solidFill>
+                        <a:srgbClr val="D6E0EA"/>
+                      </a:solidFill>
+                      <a:prstDash val="solid"/>
+                      <a:round/>
+                      <a:headEnd type="none" w="med" len="med"/>
+                      <a:tailEnd type="none" w="med" len="med"/>
+                    </a:lnT>
+                    <a:lnB w="12700" cap="flat" cmpd="sng" algn="ctr">
+                      <a:solidFill>
+                        <a:srgbClr val="D6E0EA"/>
+                      </a:solidFill>
+                      <a:prstDash val="solid"/>
+                      <a:round/>
+                      <a:headEnd type="none" w="med" len="med"/>
+                      <a:tailEnd type="none" w="med" len="med"/>
+                    </a:lnB>
+                    <a:solidFill>
+                      <a:srgbClr val="0B1F3A"/>
+                    </a:solidFill>
+                  </a:tcPr>
+                </a:tc>
+                <a:tc>
+                  <a:txBody>
+                    <a:bodyPr/>
+                    <a:lstStyle/>
+                    <a:p>
+                      <a:pPr algn="ctr" indent="0" marL="0">
+                        <a:buNone/>
+                      </a:pPr>
+                      <a:r>
+                        <a:rPr lang="en-US" sz="1150" b="1" dirty="0">
+                          <a:solidFill>
+                            <a:srgbClr val="FFFFFF"/>
+                          </a:solidFill>
+                          <a:latin typeface="Calibri" pitchFamily="34" charset="0"/>
+                          <a:ea typeface="Calibri" pitchFamily="34" charset="-122"/>
+                          <a:cs typeface="Calibri" pitchFamily="34" charset="-120"/>
+                        </a:rPr>
+                        <a:t>LSTC / Rapidus (JP)</a:t>
+                      </a:r>
+                      <a:endParaRPr lang="en-US" sz="1150" dirty="0">
+                        <a:latin typeface="Calibri" charset="0"/>
+                        <a:ea typeface="Calibri" charset="0"/>
+                        <a:cs typeface="Calibri" charset="0"/>
+                      </a:endParaRPr>
+                    </a:p>
+                  </a:txBody>
+                  <a:tcPr marL="63500" marR="63500" marT="63500" marB="63500" anchor="ctr">
+                    <a:lnL w="12700" cap="flat" cmpd="sng" algn="ctr">
+                      <a:solidFill>
+                        <a:srgbClr val="D6E0EA"/>
+                      </a:solidFill>
+                      <a:prstDash val="solid"/>
+                      <a:round/>
+                      <a:headEnd type="none" w="med" len="med"/>
+                      <a:tailEnd type="none" w="med" len="med"/>
+                    </a:lnL>
+                    <a:lnR w="12700" cap="flat" cmpd="sng" algn="ctr">
+                      <a:solidFill>
+                        <a:srgbClr val="D6E0EA"/>
+                      </a:solidFill>
+                      <a:prstDash val="solid"/>
+                      <a:round/>
+                      <a:headEnd type="none" w="med" len="med"/>
+                      <a:tailEnd type="none" w="med" len="med"/>
+                    </a:lnR>
+                    <a:lnT w="12700" cap="flat" cmpd="sng" algn="ctr">
+                      <a:solidFill>
+                        <a:srgbClr val="D6E0EA"/>
+                      </a:solidFill>
+                      <a:prstDash val="solid"/>
+                      <a:round/>
+                      <a:headEnd type="none" w="med" len="med"/>
+                      <a:tailEnd type="none" w="med" len="med"/>
+                    </a:lnT>
+                    <a:lnB w="12700" cap="flat" cmpd="sng" algn="ctr">
+                      <a:solidFill>
+                        <a:srgbClr val="D6E0EA"/>
+                      </a:solidFill>
+                      <a:prstDash val="solid"/>
+                      <a:round/>
+                      <a:headEnd type="none" w="med" len="med"/>
+                      <a:tailEnd type="none" w="med" len="med"/>
+                    </a:lnB>
+                    <a:solidFill>
+                      <a:srgbClr val="0B1F3A"/>
+                    </a:solidFill>
+                  </a:tcPr>
+                </a:tc>
+              </a:tr>
+              <a:tr h="566928">
+                <a:tc>
+                  <a:txBody>
+                    <a:bodyPr/>
+                    <a:lstStyle/>
+                    <a:p>
+                      <a:pPr indent="0" marL="0">
+                        <a:buNone/>
+                      </a:pPr>
+                      <a:r>
+                        <a:rPr lang="en-US" sz="1150" b="1" dirty="0">
+                          <a:solidFill>
+                            <a:srgbClr val="1A2B45"/>
+                          </a:solidFill>
+                          <a:latin typeface="Calibri" pitchFamily="34" charset="0"/>
+                          <a:ea typeface="Calibri" pitchFamily="34" charset="-122"/>
+                          <a:cs typeface="Calibri" pitchFamily="34" charset="-120"/>
+                        </a:rPr>
+                        <a:t>モデル</a:t>
+                      </a:r>
+                      <a:endParaRPr lang="en-US" sz="1150" dirty="0">
+                        <a:latin typeface="Calibri" charset="0"/>
+                        <a:ea typeface="Calibri" charset="0"/>
+                        <a:cs typeface="Calibri" charset="0"/>
+                      </a:endParaRPr>
+                    </a:p>
+                  </a:txBody>
+                  <a:tcPr marL="63500" marR="63500" marT="63500" marB="63500" anchor="ctr">
+                    <a:lnL w="12700" cap="flat" cmpd="sng" algn="ctr">
+                      <a:solidFill>
+                        <a:srgbClr val="D6E0EA"/>
+                      </a:solidFill>
+                      <a:prstDash val="solid"/>
+                      <a:round/>
+                      <a:headEnd type="none" w="med" len="med"/>
+                      <a:tailEnd type="none" w="med" len="med"/>
+                    </a:lnL>
+                    <a:lnR w="12700" cap="flat" cmpd="sng" algn="ctr">
+                      <a:solidFill>
+                        <a:srgbClr val="D6E0EA"/>
+                      </a:solidFill>
+                      <a:prstDash val="solid"/>
+                      <a:round/>
+                      <a:headEnd type="none" w="med" len="med"/>
+                      <a:tailEnd type="none" w="med" len="med"/>
+                    </a:lnR>
+                    <a:lnT w="12700" cap="flat" cmpd="sng" algn="ctr">
+                      <a:solidFill>
+                        <a:srgbClr val="D6E0EA"/>
+                      </a:solidFill>
+                      <a:prstDash val="solid"/>
+                      <a:round/>
+                      <a:headEnd type="none" w="med" len="med"/>
+                      <a:tailEnd type="none" w="med" len="med"/>
+                    </a:lnT>
+                    <a:lnB w="12700" cap="flat" cmpd="sng" algn="ctr">
+                      <a:solidFill>
+                        <a:srgbClr val="D6E0EA"/>
+                      </a:solidFill>
+                      <a:prstDash val="solid"/>
+                      <a:round/>
+                      <a:headEnd type="none" w="med" len="med"/>
+                      <a:tailEnd type="none" w="med" len="med"/>
+                    </a:lnB>
+                    <a:solidFill>
+                      <a:srgbClr val="EEF3F8"/>
+                    </a:solidFill>
+                  </a:tcPr>
+                </a:tc>
+                <a:tc>
+                  <a:txBody>
+                    <a:bodyPr/>
+                    <a:lstStyle/>
+                    <a:p>
+                      <a:pPr indent="0" marL="0">
+                        <a:buNone/>
+                      </a:pPr>
+                      <a:r>
+                        <a:rPr lang="en-US" sz="1150" dirty="0">
+                          <a:solidFill>
+                            <a:srgbClr val="1A2B45"/>
+                          </a:solidFill>
+                          <a:latin typeface="Calibri" pitchFamily="34" charset="0"/>
+                          <a:ea typeface="Calibri" pitchFamily="34" charset="-122"/>
+                          <a:cs typeface="Calibri" pitchFamily="34" charset="-120"/>
+                        </a:rPr>
+                        <a:t>IIAP：産業界の会費で回る中立ハブ</a:t>
+                      </a:r>
+                      <a:endParaRPr lang="en-US" sz="1150" dirty="0">
+                        <a:latin typeface="Calibri" charset="0"/>
+                        <a:ea typeface="Calibri" charset="0"/>
+                        <a:cs typeface="Calibri" charset="0"/>
+                      </a:endParaRPr>
+                    </a:p>
+                  </a:txBody>
+                  <a:tcPr marL="63500" marR="63500" marT="63500" marB="63500" anchor="ctr">
+                    <a:lnL w="12700" cap="flat" cmpd="sng" algn="ctr">
+                      <a:solidFill>
+                        <a:srgbClr val="D6E0EA"/>
+                      </a:solidFill>
+                      <a:prstDash val="solid"/>
+                      <a:round/>
+                      <a:headEnd type="none" w="med" len="med"/>
+                      <a:tailEnd type="none" w="med" len="med"/>
+                    </a:lnL>
+                    <a:lnR w="12700" cap="flat" cmpd="sng" algn="ctr">
+                      <a:solidFill>
+                        <a:srgbClr val="D6E0EA"/>
+                      </a:solidFill>
+                      <a:prstDash val="solid"/>
+                      <a:round/>
+                      <a:headEnd type="none" w="med" len="med"/>
+                      <a:tailEnd type="none" w="med" len="med"/>
+                    </a:lnR>
+                    <a:lnT w="12700" cap="flat" cmpd="sng" algn="ctr">
+                      <a:solidFill>
+                        <a:srgbClr val="D6E0EA"/>
+                      </a:solidFill>
+                      <a:prstDash val="solid"/>
+                      <a:round/>
+                      <a:headEnd type="none" w="med" len="med"/>
+                      <a:tailEnd type="none" w="med" len="med"/>
+                    </a:lnT>
+                    <a:lnB w="12700" cap="flat" cmpd="sng" algn="ctr">
+                      <a:solidFill>
+                        <a:srgbClr val="D6E0EA"/>
+                      </a:solidFill>
+                      <a:prstDash val="solid"/>
+                      <a:round/>
+                      <a:headEnd type="none" w="med" len="med"/>
+                      <a:tailEnd type="none" w="med" len="med"/>
+                    </a:lnB>
+                  </a:tcPr>
+                </a:tc>
+                <a:tc>
+                  <a:txBody>
+                    <a:bodyPr/>
+                    <a:lstStyle/>
+                    <a:p>
+                      <a:pPr indent="0" marL="0">
+                        <a:buNone/>
+                      </a:pPr>
+                      <a:r>
+                        <a:rPr lang="en-US" sz="1150" dirty="0">
+                          <a:solidFill>
+                            <a:srgbClr val="1A2B45"/>
+                          </a:solidFill>
+                          <a:latin typeface="Calibri" pitchFamily="34" charset="0"/>
+                          <a:ea typeface="Calibri" pitchFamily="34" charset="-122"/>
+                          <a:cs typeface="Calibri" pitchFamily="34" charset="-120"/>
+                        </a:rPr>
+                        <a:t>共用ライン＋コンソーシアム＋国プロ</a:t>
+                      </a:r>
+                      <a:endParaRPr lang="en-US" sz="1150" dirty="0">
+                        <a:latin typeface="Calibri" charset="0"/>
+                        <a:ea typeface="Calibri" charset="0"/>
+                        <a:cs typeface="Calibri" charset="0"/>
+                      </a:endParaRPr>
+                    </a:p>
+                  </a:txBody>
+                  <a:tcPr marL="63500" marR="63500" marT="63500" marB="63500" anchor="ctr">
+                    <a:lnL w="12700" cap="flat" cmpd="sng" algn="ctr">
+                      <a:solidFill>
+                        <a:srgbClr val="D6E0EA"/>
+                      </a:solidFill>
+                      <a:prstDash val="solid"/>
+                      <a:round/>
+                      <a:headEnd type="none" w="med" len="med"/>
+                      <a:tailEnd type="none" w="med" len="med"/>
+                    </a:lnL>
+                    <a:lnR w="12700" cap="flat" cmpd="sng" algn="ctr">
+                      <a:solidFill>
+                        <a:srgbClr val="D6E0EA"/>
+                      </a:solidFill>
+                      <a:prstDash val="solid"/>
+                      <a:round/>
+                      <a:headEnd type="none" w="med" len="med"/>
+                      <a:tailEnd type="none" w="med" len="med"/>
+                    </a:lnR>
+                    <a:lnT w="12700" cap="flat" cmpd="sng" algn="ctr">
+                      <a:solidFill>
+                        <a:srgbClr val="D6E0EA"/>
+                      </a:solidFill>
+                      <a:prstDash val="solid"/>
+                      <a:round/>
+                      <a:headEnd type="none" w="med" len="med"/>
+                      <a:tailEnd type="none" w="med" len="med"/>
+                    </a:lnT>
+                    <a:lnB w="12700" cap="flat" cmpd="sng" algn="ctr">
+                      <a:solidFill>
+                        <a:srgbClr val="D6E0EA"/>
+                      </a:solidFill>
+                      <a:prstDash val="solid"/>
+                      <a:round/>
+                      <a:headEnd type="none" w="med" len="med"/>
+                      <a:tailEnd type="none" w="med" len="med"/>
+                    </a:lnB>
+                  </a:tcPr>
+                </a:tc>
+                <a:tc>
+                  <a:txBody>
+                    <a:bodyPr/>
+                    <a:lstStyle/>
+                    <a:p>
+                      <a:pPr indent="0" marL="0">
+                        <a:buNone/>
+                      </a:pPr>
+                      <a:r>
+                        <a:rPr lang="en-US" sz="1150" dirty="0">
+                          <a:solidFill>
+                            <a:srgbClr val="1A2B45"/>
+                          </a:solidFill>
+                          <a:latin typeface="Calibri" pitchFamily="34" charset="0"/>
+                          <a:ea typeface="Calibri" pitchFamily="34" charset="-122"/>
+                          <a:cs typeface="Calibri" pitchFamily="34" charset="-120"/>
+                        </a:rPr>
+                        <a:t>束ね役 → 2nm 量産（imec/IBM 連携）</a:t>
+                      </a:r>
+                      <a:endParaRPr lang="en-US" sz="1150" dirty="0">
+                        <a:latin typeface="Calibri" charset="0"/>
+                        <a:ea typeface="Calibri" charset="0"/>
+                        <a:cs typeface="Calibri" charset="0"/>
+                      </a:endParaRPr>
+                    </a:p>
+                  </a:txBody>
+                  <a:tcPr marL="63500" marR="63500" marT="63500" marB="63500" anchor="ctr">
+                    <a:lnL w="12700" cap="flat" cmpd="sng" algn="ctr">
+                      <a:solidFill>
+                        <a:srgbClr val="D6E0EA"/>
+                      </a:solidFill>
+                      <a:prstDash val="solid"/>
+                      <a:round/>
+                      <a:headEnd type="none" w="med" len="med"/>
+                      <a:tailEnd type="none" w="med" len="med"/>
+                    </a:lnL>
+                    <a:lnR w="12700" cap="flat" cmpd="sng" algn="ctr">
+                      <a:solidFill>
+                        <a:srgbClr val="D6E0EA"/>
+                      </a:solidFill>
+                      <a:prstDash val="solid"/>
+                      <a:round/>
+                      <a:headEnd type="none" w="med" len="med"/>
+                      <a:tailEnd type="none" w="med" len="med"/>
+                    </a:lnR>
+                    <a:lnT w="12700" cap="flat" cmpd="sng" algn="ctr">
+                      <a:solidFill>
+                        <a:srgbClr val="D6E0EA"/>
+                      </a:solidFill>
+                      <a:prstDash val="solid"/>
+                      <a:round/>
+                      <a:headEnd type="none" w="med" len="med"/>
+                      <a:tailEnd type="none" w="med" len="med"/>
+                    </a:lnT>
+                    <a:lnB w="12700" cap="flat" cmpd="sng" algn="ctr">
+                      <a:solidFill>
+                        <a:srgbClr val="D6E0EA"/>
+                      </a:solidFill>
+                      <a:prstDash val="solid"/>
+                      <a:round/>
+                      <a:headEnd type="none" w="med" len="med"/>
+                      <a:tailEnd type="none" w="med" len="med"/>
+                    </a:lnB>
+                  </a:tcPr>
+                </a:tc>
+              </a:tr>
+              <a:tr h="566928">
+                <a:tc>
+                  <a:txBody>
+                    <a:bodyPr/>
+                    <a:lstStyle/>
+                    <a:p>
+                      <a:pPr indent="0" marL="0">
+                        <a:buNone/>
+                      </a:pPr>
+                      <a:r>
+                        <a:rPr lang="en-US" sz="1150" b="1" dirty="0">
+                          <a:solidFill>
+                            <a:srgbClr val="1A2B45"/>
+                          </a:solidFill>
+                          <a:latin typeface="Calibri" pitchFamily="34" charset="0"/>
+                          <a:ea typeface="Calibri" pitchFamily="34" charset="-122"/>
+                          <a:cs typeface="Calibri" pitchFamily="34" charset="-120"/>
+                        </a:rPr>
+                        <a:t>資金</a:t>
+                      </a:r>
+                      <a:endParaRPr lang="en-US" sz="1150" dirty="0">
+                        <a:latin typeface="Calibri" charset="0"/>
+                        <a:ea typeface="Calibri" charset="0"/>
+                        <a:cs typeface="Calibri" charset="0"/>
+                      </a:endParaRPr>
+                    </a:p>
+                  </a:txBody>
+                  <a:tcPr marL="63500" marR="63500" marT="63500" marB="63500" anchor="ctr">
+                    <a:lnL w="12700" cap="flat" cmpd="sng" algn="ctr">
+                      <a:solidFill>
+                        <a:srgbClr val="D6E0EA"/>
+                      </a:solidFill>
+                      <a:prstDash val="solid"/>
+                      <a:round/>
+                      <a:headEnd type="none" w="med" len="med"/>
+                      <a:tailEnd type="none" w="med" len="med"/>
+                    </a:lnL>
+                    <a:lnR w="12700" cap="flat" cmpd="sng" algn="ctr">
+                      <a:solidFill>
+                        <a:srgbClr val="D6E0EA"/>
+                      </a:solidFill>
+                      <a:prstDash val="solid"/>
+                      <a:round/>
+                      <a:headEnd type="none" w="med" len="med"/>
+                      <a:tailEnd type="none" w="med" len="med"/>
+                    </a:lnR>
+                    <a:lnT w="12700" cap="flat" cmpd="sng" algn="ctr">
+                      <a:solidFill>
+                        <a:srgbClr val="D6E0EA"/>
+                      </a:solidFill>
+                      <a:prstDash val="solid"/>
+                      <a:round/>
+                      <a:headEnd type="none" w="med" len="med"/>
+                      <a:tailEnd type="none" w="med" len="med"/>
+                    </a:lnT>
+                    <a:lnB w="12700" cap="flat" cmpd="sng" algn="ctr">
+                      <a:solidFill>
+                        <a:srgbClr val="D6E0EA"/>
+                      </a:solidFill>
+                      <a:prstDash val="solid"/>
+                      <a:round/>
+                      <a:headEnd type="none" w="med" len="med"/>
+                      <a:tailEnd type="none" w="med" len="med"/>
+                    </a:lnB>
+                    <a:solidFill>
+                      <a:srgbClr val="EEF3F8"/>
+                    </a:solidFill>
+                  </a:tcPr>
+                </a:tc>
+                <a:tc>
+                  <a:txBody>
+                    <a:bodyPr/>
+                    <a:lstStyle/>
+                    <a:p>
+                      <a:pPr indent="0" marL="0">
+                        <a:buNone/>
+                      </a:pPr>
+                      <a:r>
+                        <a:rPr lang="en-US" sz="1150" dirty="0">
+                          <a:solidFill>
+                            <a:srgbClr val="1A2B45"/>
+                          </a:solidFill>
+                          <a:latin typeface="Calibri" pitchFamily="34" charset="0"/>
+                          <a:ea typeface="Calibri" pitchFamily="34" charset="-122"/>
+                          <a:cs typeface="Calibri" pitchFamily="34" charset="-120"/>
+                        </a:rPr>
+                        <a:t>会費主体・政府 ~15%（~€8–9 億/年）</a:t>
+                      </a:r>
+                      <a:endParaRPr lang="en-US" sz="1150" dirty="0">
+                        <a:latin typeface="Calibri" charset="0"/>
+                        <a:ea typeface="Calibri" charset="0"/>
+                        <a:cs typeface="Calibri" charset="0"/>
+                      </a:endParaRPr>
+                    </a:p>
+                  </a:txBody>
+                  <a:tcPr marL="63500" marR="63500" marT="63500" marB="63500" anchor="ctr">
+                    <a:lnL w="12700" cap="flat" cmpd="sng" algn="ctr">
+                      <a:solidFill>
+                        <a:srgbClr val="D6E0EA"/>
+                      </a:solidFill>
+                      <a:prstDash val="solid"/>
+                      <a:round/>
+                      <a:headEnd type="none" w="med" len="med"/>
+                      <a:tailEnd type="none" w="med" len="med"/>
+                    </a:lnL>
+                    <a:lnR w="12700" cap="flat" cmpd="sng" algn="ctr">
+                      <a:solidFill>
+                        <a:srgbClr val="D6E0EA"/>
+                      </a:solidFill>
+                      <a:prstDash val="solid"/>
+                      <a:round/>
+                      <a:headEnd type="none" w="med" len="med"/>
+                      <a:tailEnd type="none" w="med" len="med"/>
+                    </a:lnR>
+                    <a:lnT w="12700" cap="flat" cmpd="sng" algn="ctr">
+                      <a:solidFill>
+                        <a:srgbClr val="D6E0EA"/>
+                      </a:solidFill>
+                      <a:prstDash val="solid"/>
+                      <a:round/>
+                      <a:headEnd type="none" w="med" len="med"/>
+                      <a:tailEnd type="none" w="med" len="med"/>
+                    </a:lnT>
+                    <a:lnB w="12700" cap="flat" cmpd="sng" algn="ctr">
+                      <a:solidFill>
+                        <a:srgbClr val="D6E0EA"/>
+                      </a:solidFill>
+                      <a:prstDash val="solid"/>
+                      <a:round/>
+                      <a:headEnd type="none" w="med" len="med"/>
+                      <a:tailEnd type="none" w="med" len="med"/>
+                    </a:lnB>
+                  </a:tcPr>
+                </a:tc>
+                <a:tc>
+                  <a:txBody>
+                    <a:bodyPr/>
+                    <a:lstStyle/>
+                    <a:p>
+                      <a:pPr indent="0" marL="0">
+                        <a:buNone/>
+                      </a:pPr>
+                      <a:r>
+                        <a:rPr lang="en-US" sz="1150" dirty="0">
+                          <a:solidFill>
+                            <a:srgbClr val="1A2B45"/>
+                          </a:solidFill>
+                          <a:latin typeface="Calibri" pitchFamily="34" charset="0"/>
+                          <a:ea typeface="Calibri" pitchFamily="34" charset="-122"/>
+                          <a:cs typeface="Calibri" pitchFamily="34" charset="-120"/>
+                        </a:rPr>
+                        <a:t>国費（運営費交付金）主体・~1,000 億/年</a:t>
+                      </a:r>
+                      <a:endParaRPr lang="en-US" sz="1150" dirty="0">
+                        <a:latin typeface="Calibri" charset="0"/>
+                        <a:ea typeface="Calibri" charset="0"/>
+                        <a:cs typeface="Calibri" charset="0"/>
+                      </a:endParaRPr>
+                    </a:p>
+                  </a:txBody>
+                  <a:tcPr marL="63500" marR="63500" marT="63500" marB="63500" anchor="ctr">
+                    <a:lnL w="12700" cap="flat" cmpd="sng" algn="ctr">
+                      <a:solidFill>
+                        <a:srgbClr val="D6E0EA"/>
+                      </a:solidFill>
+                      <a:prstDash val="solid"/>
+                      <a:round/>
+                      <a:headEnd type="none" w="med" len="med"/>
+                      <a:tailEnd type="none" w="med" len="med"/>
+                    </a:lnL>
+                    <a:lnR w="12700" cap="flat" cmpd="sng" algn="ctr">
+                      <a:solidFill>
+                        <a:srgbClr val="D6E0EA"/>
+                      </a:solidFill>
+                      <a:prstDash val="solid"/>
+                      <a:round/>
+                      <a:headEnd type="none" w="med" len="med"/>
+                      <a:tailEnd type="none" w="med" len="med"/>
+                    </a:lnR>
+                    <a:lnT w="12700" cap="flat" cmpd="sng" algn="ctr">
+                      <a:solidFill>
+                        <a:srgbClr val="D6E0EA"/>
+                      </a:solidFill>
+                      <a:prstDash val="solid"/>
+                      <a:round/>
+                      <a:headEnd type="none" w="med" len="med"/>
+                      <a:tailEnd type="none" w="med" len="med"/>
+                    </a:lnT>
+                    <a:lnB w="12700" cap="flat" cmpd="sng" algn="ctr">
+                      <a:solidFill>
+                        <a:srgbClr val="D6E0EA"/>
+                      </a:solidFill>
+                      <a:prstDash val="solid"/>
+                      <a:round/>
+                      <a:headEnd type="none" w="med" len="med"/>
+                      <a:tailEnd type="none" w="med" len="med"/>
+                    </a:lnB>
+                  </a:tcPr>
+                </a:tc>
+                <a:tc>
+                  <a:txBody>
+                    <a:bodyPr/>
+                    <a:lstStyle/>
+                    <a:p>
+                      <a:pPr indent="0" marL="0">
+                        <a:buNone/>
+                      </a:pPr>
+                      <a:r>
+                        <a:rPr lang="en-US" sz="1150" dirty="0">
+                          <a:solidFill>
+                            <a:srgbClr val="1A2B45"/>
+                          </a:solidFill>
+                          <a:latin typeface="Calibri" pitchFamily="34" charset="0"/>
+                          <a:ea typeface="Calibri" pitchFamily="34" charset="-122"/>
+                          <a:cs typeface="Calibri" pitchFamily="34" charset="-120"/>
+                        </a:rPr>
+                        <a:t>国費（経産/NEDO）中心</a:t>
+                      </a:r>
+                      <a:endParaRPr lang="en-US" sz="1150" dirty="0">
+                        <a:latin typeface="Calibri" charset="0"/>
+                        <a:ea typeface="Calibri" charset="0"/>
+                        <a:cs typeface="Calibri" charset="0"/>
+                      </a:endParaRPr>
+                    </a:p>
+                  </a:txBody>
+                  <a:tcPr marL="63500" marR="63500" marT="63500" marB="63500" anchor="ctr">
+                    <a:lnL w="12700" cap="flat" cmpd="sng" algn="ctr">
+                      <a:solidFill>
+                        <a:srgbClr val="D6E0EA"/>
+                      </a:solidFill>
+                      <a:prstDash val="solid"/>
+                      <a:round/>
+                      <a:headEnd type="none" w="med" len="med"/>
+                      <a:tailEnd type="none" w="med" len="med"/>
+                    </a:lnL>
+                    <a:lnR w="12700" cap="flat" cmpd="sng" algn="ctr">
+                      <a:solidFill>
+                        <a:srgbClr val="D6E0EA"/>
+                      </a:solidFill>
+                      <a:prstDash val="solid"/>
+                      <a:round/>
+                      <a:headEnd type="none" w="med" len="med"/>
+                      <a:tailEnd type="none" w="med" len="med"/>
+                    </a:lnR>
+                    <a:lnT w="12700" cap="flat" cmpd="sng" algn="ctr">
+                      <a:solidFill>
+                        <a:srgbClr val="D6E0EA"/>
+                      </a:solidFill>
+                      <a:prstDash val="solid"/>
+                      <a:round/>
+                      <a:headEnd type="none" w="med" len="med"/>
+                      <a:tailEnd type="none" w="med" len="med"/>
+                    </a:lnT>
+                    <a:lnB w="12700" cap="flat" cmpd="sng" algn="ctr">
+                      <a:solidFill>
+                        <a:srgbClr val="D6E0EA"/>
+                      </a:solidFill>
+                      <a:prstDash val="solid"/>
+                      <a:round/>
+                      <a:headEnd type="none" w="med" len="med"/>
+                      <a:tailEnd type="none" w="med" len="med"/>
+                    </a:lnB>
+                  </a:tcPr>
+                </a:tc>
+              </a:tr>
+              <a:tr h="566928">
+                <a:tc>
+                  <a:txBody>
+                    <a:bodyPr/>
+                    <a:lstStyle/>
+                    <a:p>
+                      <a:pPr indent="0" marL="0">
+                        <a:buNone/>
+                      </a:pPr>
+                      <a:r>
+                        <a:rPr lang="en-US" sz="1150" b="1" dirty="0">
+                          <a:solidFill>
+                            <a:srgbClr val="1A2B45"/>
+                          </a:solidFill>
+                          <a:latin typeface="Calibri" pitchFamily="34" charset="0"/>
+                          <a:ea typeface="Calibri" pitchFamily="34" charset="-122"/>
+                          <a:cs typeface="Calibri" pitchFamily="34" charset="-120"/>
+                        </a:rPr>
+                        <a:t>参加・IP</a:t>
+                      </a:r>
+                      <a:endParaRPr lang="en-US" sz="1150" dirty="0">
+                        <a:latin typeface="Calibri" charset="0"/>
+                        <a:ea typeface="Calibri" charset="0"/>
+                        <a:cs typeface="Calibri" charset="0"/>
+                      </a:endParaRPr>
+                    </a:p>
+                  </a:txBody>
+                  <a:tcPr marL="63500" marR="63500" marT="63500" marB="63500" anchor="ctr">
+                    <a:lnL w="12700" cap="flat" cmpd="sng" algn="ctr">
+                      <a:solidFill>
+                        <a:srgbClr val="D6E0EA"/>
+                      </a:solidFill>
+                      <a:prstDash val="solid"/>
+                      <a:round/>
+                      <a:headEnd type="none" w="med" len="med"/>
+                      <a:tailEnd type="none" w="med" len="med"/>
+                    </a:lnL>
+                    <a:lnR w="12700" cap="flat" cmpd="sng" algn="ctr">
+                      <a:solidFill>
+                        <a:srgbClr val="D6E0EA"/>
+                      </a:solidFill>
+                      <a:prstDash val="solid"/>
+                      <a:round/>
+                      <a:headEnd type="none" w="med" len="med"/>
+                      <a:tailEnd type="none" w="med" len="med"/>
+                    </a:lnR>
+                    <a:lnT w="12700" cap="flat" cmpd="sng" algn="ctr">
+                      <a:solidFill>
+                        <a:srgbClr val="D6E0EA"/>
+                      </a:solidFill>
+                      <a:prstDash val="solid"/>
+                      <a:round/>
+                      <a:headEnd type="none" w="med" len="med"/>
+                      <a:tailEnd type="none" w="med" len="med"/>
+                    </a:lnT>
+                    <a:lnB w="12700" cap="flat" cmpd="sng" algn="ctr">
+                      <a:solidFill>
+                        <a:srgbClr val="D6E0EA"/>
+                      </a:solidFill>
+                      <a:prstDash val="solid"/>
+                      <a:round/>
+                      <a:headEnd type="none" w="med" len="med"/>
+                      <a:tailEnd type="none" w="med" len="med"/>
+                    </a:lnB>
+                    <a:solidFill>
+                      <a:srgbClr val="EEF3F8"/>
+                    </a:solidFill>
+                  </a:tcPr>
+                </a:tc>
+                <a:tc>
+                  <a:txBody>
+                    <a:bodyPr/>
+                    <a:lstStyle/>
+                    <a:p>
+                      <a:pPr indent="0" marL="0">
+                        <a:buNone/>
+                      </a:pPr>
+                      <a:r>
+                        <a:rPr lang="en-US" sz="1150" dirty="0">
+                          <a:solidFill>
+                            <a:srgbClr val="1A2B45"/>
+                          </a:solidFill>
+                          <a:latin typeface="Calibri" pitchFamily="34" charset="0"/>
+                          <a:ea typeface="Calibri" pitchFamily="34" charset="-122"/>
+                          <a:cs typeface="Calibri" pitchFamily="34" charset="-120"/>
+                        </a:rPr>
+                        <a:t>出資に応じた階層アクセス</a:t>
+                      </a:r>
+                      <a:endParaRPr lang="en-US" sz="1150" dirty="0">
+                        <a:latin typeface="Calibri" charset="0"/>
+                        <a:ea typeface="Calibri" charset="0"/>
+                        <a:cs typeface="Calibri" charset="0"/>
+                      </a:endParaRPr>
+                    </a:p>
+                  </a:txBody>
+                  <a:tcPr marL="63500" marR="63500" marT="63500" marB="63500" anchor="ctr">
+                    <a:lnL w="12700" cap="flat" cmpd="sng" algn="ctr">
+                      <a:solidFill>
+                        <a:srgbClr val="D6E0EA"/>
+                      </a:solidFill>
+                      <a:prstDash val="solid"/>
+                      <a:round/>
+                      <a:headEnd type="none" w="med" len="med"/>
+                      <a:tailEnd type="none" w="med" len="med"/>
+                    </a:lnL>
+                    <a:lnR w="12700" cap="flat" cmpd="sng" algn="ctr">
+                      <a:solidFill>
+                        <a:srgbClr val="D6E0EA"/>
+                      </a:solidFill>
+                      <a:prstDash val="solid"/>
+                      <a:round/>
+                      <a:headEnd type="none" w="med" len="med"/>
+                      <a:tailEnd type="none" w="med" len="med"/>
+                    </a:lnR>
+                    <a:lnT w="12700" cap="flat" cmpd="sng" algn="ctr">
+                      <a:solidFill>
+                        <a:srgbClr val="D6E0EA"/>
+                      </a:solidFill>
+                      <a:prstDash val="solid"/>
+                      <a:round/>
+                      <a:headEnd type="none" w="med" len="med"/>
+                      <a:tailEnd type="none" w="med" len="med"/>
+                    </a:lnT>
+                    <a:lnB w="12700" cap="flat" cmpd="sng" algn="ctr">
+                      <a:solidFill>
+                        <a:srgbClr val="D6E0EA"/>
+                      </a:solidFill>
+                      <a:prstDash val="solid"/>
+                      <a:round/>
+                      <a:headEnd type="none" w="med" len="med"/>
+                      <a:tailEnd type="none" w="med" len="med"/>
+                    </a:lnB>
+                  </a:tcPr>
+                </a:tc>
+                <a:tc>
+                  <a:txBody>
+                    <a:bodyPr/>
+                    <a:lstStyle/>
+                    <a:p>
+                      <a:pPr indent="0" marL="0">
+                        <a:buNone/>
+                      </a:pPr>
+                      <a:r>
+                        <a:rPr lang="en-US" sz="1150" dirty="0">
+                          <a:solidFill>
+                            <a:srgbClr val="1A2B45"/>
+                          </a:solidFill>
+                          <a:latin typeface="Calibri" pitchFamily="34" charset="0"/>
+                          <a:ea typeface="Calibri" pitchFamily="34" charset="-122"/>
+                          <a:cs typeface="Calibri" pitchFamily="34" charset="-120"/>
+                        </a:rPr>
+                        <a:t>会員制／助成は事業者帰属</a:t>
+                      </a:r>
+                      <a:endParaRPr lang="en-US" sz="1150" dirty="0">
+                        <a:latin typeface="Calibri" charset="0"/>
+                        <a:ea typeface="Calibri" charset="0"/>
+                        <a:cs typeface="Calibri" charset="0"/>
+                      </a:endParaRPr>
+                    </a:p>
+                  </a:txBody>
+                  <a:tcPr marL="63500" marR="63500" marT="63500" marB="63500" anchor="ctr">
+                    <a:lnL w="12700" cap="flat" cmpd="sng" algn="ctr">
+                      <a:solidFill>
+                        <a:srgbClr val="D6E0EA"/>
+                      </a:solidFill>
+                      <a:prstDash val="solid"/>
+                      <a:round/>
+                      <a:headEnd type="none" w="med" len="med"/>
+                      <a:tailEnd type="none" w="med" len="med"/>
+                    </a:lnL>
+                    <a:lnR w="12700" cap="flat" cmpd="sng" algn="ctr">
+                      <a:solidFill>
+                        <a:srgbClr val="D6E0EA"/>
+                      </a:solidFill>
+                      <a:prstDash val="solid"/>
+                      <a:round/>
+                      <a:headEnd type="none" w="med" len="med"/>
+                      <a:tailEnd type="none" w="med" len="med"/>
+                    </a:lnR>
+                    <a:lnT w="12700" cap="flat" cmpd="sng" algn="ctr">
+                      <a:solidFill>
+                        <a:srgbClr val="D6E0EA"/>
+                      </a:solidFill>
+                      <a:prstDash val="solid"/>
+                      <a:round/>
+                      <a:headEnd type="none" w="med" len="med"/>
+                      <a:tailEnd type="none" w="med" len="med"/>
+                    </a:lnT>
+                    <a:lnB w="12700" cap="flat" cmpd="sng" algn="ctr">
+                      <a:solidFill>
+                        <a:srgbClr val="D6E0EA"/>
+                      </a:solidFill>
+                      <a:prstDash val="solid"/>
+                      <a:round/>
+                      <a:headEnd type="none" w="med" len="med"/>
+                      <a:tailEnd type="none" w="med" len="med"/>
+                    </a:lnB>
+                  </a:tcPr>
+                </a:tc>
+                <a:tc>
+                  <a:txBody>
+                    <a:bodyPr/>
+                    <a:lstStyle/>
+                    <a:p>
+                      <a:pPr indent="0" marL="0">
+                        <a:buNone/>
+                      </a:pPr>
+                      <a:r>
+                        <a:rPr lang="en-US" sz="1150" dirty="0">
+                          <a:solidFill>
+                            <a:srgbClr val="1A2B45"/>
+                          </a:solidFill>
+                          <a:latin typeface="Calibri" pitchFamily="34" charset="0"/>
+                          <a:ea typeface="Calibri" pitchFamily="34" charset="-122"/>
+                          <a:cs typeface="Calibri" pitchFamily="34" charset="-120"/>
+                        </a:rPr>
+                        <a:t>組合員・企業帰属</a:t>
+                      </a:r>
+                      <a:endParaRPr lang="en-US" sz="1150" dirty="0">
+                        <a:latin typeface="Calibri" charset="0"/>
+                        <a:ea typeface="Calibri" charset="0"/>
+                        <a:cs typeface="Calibri" charset="0"/>
+                      </a:endParaRPr>
+                    </a:p>
+                  </a:txBody>
+                  <a:tcPr marL="63500" marR="63500" marT="63500" marB="63500" anchor="ctr">
+                    <a:lnL w="12700" cap="flat" cmpd="sng" algn="ctr">
+                      <a:solidFill>
+                        <a:srgbClr val="D6E0EA"/>
+                      </a:solidFill>
+                      <a:prstDash val="solid"/>
+                      <a:round/>
+                      <a:headEnd type="none" w="med" len="med"/>
+                      <a:tailEnd type="none" w="med" len="med"/>
+                    </a:lnL>
+                    <a:lnR w="12700" cap="flat" cmpd="sng" algn="ctr">
+                      <a:solidFill>
+                        <a:srgbClr val="D6E0EA"/>
+                      </a:solidFill>
+                      <a:prstDash val="solid"/>
+                      <a:round/>
+                      <a:headEnd type="none" w="med" len="med"/>
+                      <a:tailEnd type="none" w="med" len="med"/>
+                    </a:lnR>
+                    <a:lnT w="12700" cap="flat" cmpd="sng" algn="ctr">
+                      <a:solidFill>
+                        <a:srgbClr val="D6E0EA"/>
+                      </a:solidFill>
+                      <a:prstDash val="solid"/>
+                      <a:round/>
+                      <a:headEnd type="none" w="med" len="med"/>
+                      <a:tailEnd type="none" w="med" len="med"/>
+                    </a:lnT>
+                    <a:lnB w="12700" cap="flat" cmpd="sng" algn="ctr">
+                      <a:solidFill>
+                        <a:srgbClr val="D6E0EA"/>
+                      </a:solidFill>
+                      <a:prstDash val="solid"/>
+                      <a:round/>
+                      <a:headEnd type="none" w="med" len="med"/>
+                      <a:tailEnd type="none" w="med" len="med"/>
+                    </a:lnB>
+                  </a:tcPr>
+                </a:tc>
+              </a:tr>
+              <a:tr h="566928">
+                <a:tc>
+                  <a:txBody>
+                    <a:bodyPr/>
+                    <a:lstStyle/>
+                    <a:p>
+                      <a:pPr indent="0" marL="0">
+                        <a:buNone/>
+                      </a:pPr>
+                      <a:r>
+                        <a:rPr lang="en-US" sz="1150" b="1" dirty="0">
+                          <a:solidFill>
+                            <a:srgbClr val="1A2B45"/>
+                          </a:solidFill>
+                          <a:latin typeface="Calibri" pitchFamily="34" charset="0"/>
+                          <a:ea typeface="Calibri" pitchFamily="34" charset="-122"/>
+                          <a:cs typeface="Calibri" pitchFamily="34" charset="-120"/>
+                        </a:rPr>
+                        <a:t>強み</a:t>
+                      </a:r>
+                      <a:endParaRPr lang="en-US" sz="1150" dirty="0">
+                        <a:latin typeface="Calibri" charset="0"/>
+                        <a:ea typeface="Calibri" charset="0"/>
+                        <a:cs typeface="Calibri" charset="0"/>
+                      </a:endParaRPr>
+                    </a:p>
+                  </a:txBody>
+                  <a:tcPr marL="63500" marR="63500" marT="63500" marB="63500" anchor="ctr">
+                    <a:lnL w="12700" cap="flat" cmpd="sng" algn="ctr">
+                      <a:solidFill>
+                        <a:srgbClr val="D6E0EA"/>
+                      </a:solidFill>
+                      <a:prstDash val="solid"/>
+                      <a:round/>
+                      <a:headEnd type="none" w="med" len="med"/>
+                      <a:tailEnd type="none" w="med" len="med"/>
+                    </a:lnL>
+                    <a:lnR w="12700" cap="flat" cmpd="sng" algn="ctr">
+                      <a:solidFill>
+                        <a:srgbClr val="D6E0EA"/>
+                      </a:solidFill>
+                      <a:prstDash val="solid"/>
+                      <a:round/>
+                      <a:headEnd type="none" w="med" len="med"/>
+                      <a:tailEnd type="none" w="med" len="med"/>
+                    </a:lnR>
+                    <a:lnT w="12700" cap="flat" cmpd="sng" algn="ctr">
+                      <a:solidFill>
+                        <a:srgbClr val="D6E0EA"/>
+                      </a:solidFill>
+                      <a:prstDash val="solid"/>
+                      <a:round/>
+                      <a:headEnd type="none" w="med" len="med"/>
+                      <a:tailEnd type="none" w="med" len="med"/>
+                    </a:lnT>
+                    <a:lnB w="12700" cap="flat" cmpd="sng" algn="ctr">
+                      <a:solidFill>
+                        <a:srgbClr val="D6E0EA"/>
+                      </a:solidFill>
+                      <a:prstDash val="solid"/>
+                      <a:round/>
+                      <a:headEnd type="none" w="med" len="med"/>
+                      <a:tailEnd type="none" w="med" len="med"/>
+                    </a:lnB>
+                    <a:solidFill>
+                      <a:srgbClr val="EEF3F8"/>
+                    </a:solidFill>
+                  </a:tcPr>
+                </a:tc>
+                <a:tc>
+                  <a:txBody>
+                    <a:bodyPr/>
+                    <a:lstStyle/>
+                    <a:p>
+                      <a:pPr indent="0" marL="0">
+                        <a:buNone/>
+                      </a:pPr>
+                      <a:r>
+                        <a:rPr lang="en-US" sz="1150" dirty="0">
+                          <a:solidFill>
+                            <a:srgbClr val="1A2B45"/>
+                          </a:solidFill>
+                          <a:latin typeface="Calibri" pitchFamily="34" charset="0"/>
+                          <a:ea typeface="Calibri" pitchFamily="34" charset="-122"/>
+                          <a:cs typeface="Calibri" pitchFamily="34" charset="-120"/>
+                        </a:rPr>
+                        <a:t>中立・グローバル・意思決定が速い</a:t>
+                      </a:r>
+                      <a:endParaRPr lang="en-US" sz="1150" dirty="0">
+                        <a:latin typeface="Calibri" charset="0"/>
+                        <a:ea typeface="Calibri" charset="0"/>
+                        <a:cs typeface="Calibri" charset="0"/>
+                      </a:endParaRPr>
+                    </a:p>
+                  </a:txBody>
+                  <a:tcPr marL="63500" marR="63500" marT="63500" marB="63500" anchor="ctr">
+                    <a:lnL w="12700" cap="flat" cmpd="sng" algn="ctr">
+                      <a:solidFill>
+                        <a:srgbClr val="D6E0EA"/>
+                      </a:solidFill>
+                      <a:prstDash val="solid"/>
+                      <a:round/>
+                      <a:headEnd type="none" w="med" len="med"/>
+                      <a:tailEnd type="none" w="med" len="med"/>
+                    </a:lnL>
+                    <a:lnR w="12700" cap="flat" cmpd="sng" algn="ctr">
+                      <a:solidFill>
+                        <a:srgbClr val="D6E0EA"/>
+                      </a:solidFill>
+                      <a:prstDash val="solid"/>
+                      <a:round/>
+                      <a:headEnd type="none" w="med" len="med"/>
+                      <a:tailEnd type="none" w="med" len="med"/>
+                    </a:lnR>
+                    <a:lnT w="12700" cap="flat" cmpd="sng" algn="ctr">
+                      <a:solidFill>
+                        <a:srgbClr val="D6E0EA"/>
+                      </a:solidFill>
+                      <a:prstDash val="solid"/>
+                      <a:round/>
+                      <a:headEnd type="none" w="med" len="med"/>
+                      <a:tailEnd type="none" w="med" len="med"/>
+                    </a:lnT>
+                    <a:lnB w="12700" cap="flat" cmpd="sng" algn="ctr">
+                      <a:solidFill>
+                        <a:srgbClr val="D6E0EA"/>
+                      </a:solidFill>
+                      <a:prstDash val="solid"/>
+                      <a:round/>
+                      <a:headEnd type="none" w="med" len="med"/>
+                      <a:tailEnd type="none" w="med" len="med"/>
+                    </a:lnB>
+                  </a:tcPr>
+                </a:tc>
+                <a:tc>
+                  <a:txBody>
+                    <a:bodyPr/>
+                    <a:lstStyle/>
+                    <a:p>
+                      <a:pPr indent="0" marL="0">
+                        <a:buNone/>
+                      </a:pPr>
+                      <a:r>
+                        <a:rPr lang="en-US" sz="1150" dirty="0">
+                          <a:solidFill>
+                            <a:srgbClr val="1A2B45"/>
+                          </a:solidFill>
+                          <a:latin typeface="Calibri" pitchFamily="34" charset="0"/>
+                          <a:ea typeface="Calibri" pitchFamily="34" charset="-122"/>
+                          <a:cs typeface="Calibri" pitchFamily="34" charset="-120"/>
+                        </a:rPr>
+                        <a:t>計量標準・材料・中立インフラ</a:t>
+                      </a:r>
+                      <a:endParaRPr lang="en-US" sz="1150" dirty="0">
+                        <a:latin typeface="Calibri" charset="0"/>
+                        <a:ea typeface="Calibri" charset="0"/>
+                        <a:cs typeface="Calibri" charset="0"/>
+                      </a:endParaRPr>
+                    </a:p>
+                  </a:txBody>
+                  <a:tcPr marL="63500" marR="63500" marT="63500" marB="63500" anchor="ctr">
+                    <a:lnL w="12700" cap="flat" cmpd="sng" algn="ctr">
+                      <a:solidFill>
+                        <a:srgbClr val="D6E0EA"/>
+                      </a:solidFill>
+                      <a:prstDash val="solid"/>
+                      <a:round/>
+                      <a:headEnd type="none" w="med" len="med"/>
+                      <a:tailEnd type="none" w="med" len="med"/>
+                    </a:lnL>
+                    <a:lnR w="12700" cap="flat" cmpd="sng" algn="ctr">
+                      <a:solidFill>
+                        <a:srgbClr val="D6E0EA"/>
+                      </a:solidFill>
+                      <a:prstDash val="solid"/>
+                      <a:round/>
+                      <a:headEnd type="none" w="med" len="med"/>
+                      <a:tailEnd type="none" w="med" len="med"/>
+                    </a:lnR>
+                    <a:lnT w="12700" cap="flat" cmpd="sng" algn="ctr">
+                      <a:solidFill>
+                        <a:srgbClr val="D6E0EA"/>
+                      </a:solidFill>
+                      <a:prstDash val="solid"/>
+                      <a:round/>
+                      <a:headEnd type="none" w="med" len="med"/>
+                      <a:tailEnd type="none" w="med" len="med"/>
+                    </a:lnT>
+                    <a:lnB w="12700" cap="flat" cmpd="sng" algn="ctr">
+                      <a:solidFill>
+                        <a:srgbClr val="D6E0EA"/>
+                      </a:solidFill>
+                      <a:prstDash val="solid"/>
+                      <a:round/>
+                      <a:headEnd type="none" w="med" len="med"/>
+                      <a:tailEnd type="none" w="med" len="med"/>
+                    </a:lnB>
+                  </a:tcPr>
+                </a:tc>
+                <a:tc>
+                  <a:txBody>
+                    <a:bodyPr/>
+                    <a:lstStyle/>
+                    <a:p>
+                      <a:pPr indent="0" marL="0">
+                        <a:buNone/>
+                      </a:pPr>
+                      <a:r>
+                        <a:rPr lang="en-US" sz="1150" dirty="0">
+                          <a:solidFill>
+                            <a:srgbClr val="1A2B45"/>
+                          </a:solidFill>
+                          <a:latin typeface="Calibri" pitchFamily="34" charset="0"/>
+                          <a:ea typeface="Calibri" pitchFamily="34" charset="-122"/>
+                          <a:cs typeface="Calibri" pitchFamily="34" charset="-120"/>
+                        </a:rPr>
+                        <a:t>量産直結・海外連携</a:t>
+                      </a:r>
+                      <a:endParaRPr lang="en-US" sz="1150" dirty="0">
+                        <a:latin typeface="Calibri" charset="0"/>
+                        <a:ea typeface="Calibri" charset="0"/>
+                        <a:cs typeface="Calibri" charset="0"/>
+                      </a:endParaRPr>
+                    </a:p>
+                  </a:txBody>
+                  <a:tcPr marL="63500" marR="63500" marT="63500" marB="63500" anchor="ctr">
+                    <a:lnL w="12700" cap="flat" cmpd="sng" algn="ctr">
+                      <a:solidFill>
+                        <a:srgbClr val="D6E0EA"/>
+                      </a:solidFill>
+                      <a:prstDash val="solid"/>
+                      <a:round/>
+                      <a:headEnd type="none" w="med" len="med"/>
+                      <a:tailEnd type="none" w="med" len="med"/>
+                    </a:lnL>
+                    <a:lnR w="12700" cap="flat" cmpd="sng" algn="ctr">
+                      <a:solidFill>
+                        <a:srgbClr val="D6E0EA"/>
+                      </a:solidFill>
+                      <a:prstDash val="solid"/>
+                      <a:round/>
+                      <a:headEnd type="none" w="med" len="med"/>
+                      <a:tailEnd type="none" w="med" len="med"/>
+                    </a:lnR>
+                    <a:lnT w="12700" cap="flat" cmpd="sng" algn="ctr">
+                      <a:solidFill>
+                        <a:srgbClr val="D6E0EA"/>
+                      </a:solidFill>
+                      <a:prstDash val="solid"/>
+                      <a:round/>
+                      <a:headEnd type="none" w="med" len="med"/>
+                      <a:tailEnd type="none" w="med" len="med"/>
+                    </a:lnT>
+                    <a:lnB w="12700" cap="flat" cmpd="sng" algn="ctr">
+                      <a:solidFill>
+                        <a:srgbClr val="D6E0EA"/>
+                      </a:solidFill>
+                      <a:prstDash val="solid"/>
+                      <a:round/>
+                      <a:headEnd type="none" w="med" len="med"/>
+                      <a:tailEnd type="none" w="med" len="med"/>
+                    </a:lnB>
+                  </a:tcPr>
+                </a:tc>
+              </a:tr>
+              <a:tr h="566928">
+                <a:tc>
+                  <a:txBody>
+                    <a:bodyPr/>
+                    <a:lstStyle/>
+                    <a:p>
+                      <a:pPr indent="0" marL="0">
+                        <a:buNone/>
+                      </a:pPr>
+                      <a:r>
+                        <a:rPr lang="en-US" sz="1150" b="1" dirty="0">
+                          <a:solidFill>
+                            <a:srgbClr val="1A2B45"/>
+                          </a:solidFill>
+                          <a:latin typeface="Calibri" pitchFamily="34" charset="0"/>
+                          <a:ea typeface="Calibri" pitchFamily="34" charset="-122"/>
+                          <a:cs typeface="Calibri" pitchFamily="34" charset="-120"/>
+                        </a:rPr>
+                        <a:t>弱み</a:t>
+                      </a:r>
+                      <a:endParaRPr lang="en-US" sz="1150" dirty="0">
+                        <a:latin typeface="Calibri" charset="0"/>
+                        <a:ea typeface="Calibri" charset="0"/>
+                        <a:cs typeface="Calibri" charset="0"/>
+                      </a:endParaRPr>
+                    </a:p>
+                  </a:txBody>
+                  <a:tcPr marL="63500" marR="63500" marT="63500" marB="63500" anchor="ctr">
+                    <a:lnL w="12700" cap="flat" cmpd="sng" algn="ctr">
+                      <a:solidFill>
+                        <a:srgbClr val="D6E0EA"/>
+                      </a:solidFill>
+                      <a:prstDash val="solid"/>
+                      <a:round/>
+                      <a:headEnd type="none" w="med" len="med"/>
+                      <a:tailEnd type="none" w="med" len="med"/>
+                    </a:lnL>
+                    <a:lnR w="12700" cap="flat" cmpd="sng" algn="ctr">
+                      <a:solidFill>
+                        <a:srgbClr val="D6E0EA"/>
+                      </a:solidFill>
+                      <a:prstDash val="solid"/>
+                      <a:round/>
+                      <a:headEnd type="none" w="med" len="med"/>
+                      <a:tailEnd type="none" w="med" len="med"/>
+                    </a:lnR>
+                    <a:lnT w="12700" cap="flat" cmpd="sng" algn="ctr">
+                      <a:solidFill>
+                        <a:srgbClr val="D6E0EA"/>
+                      </a:solidFill>
+                      <a:prstDash val="solid"/>
+                      <a:round/>
+                      <a:headEnd type="none" w="med" len="med"/>
+                      <a:tailEnd type="none" w="med" len="med"/>
+                    </a:lnT>
+                    <a:lnB w="12700" cap="flat" cmpd="sng" algn="ctr">
+                      <a:solidFill>
+                        <a:srgbClr val="D6E0EA"/>
+                      </a:solidFill>
+                      <a:prstDash val="solid"/>
+                      <a:round/>
+                      <a:headEnd type="none" w="med" len="med"/>
+                      <a:tailEnd type="none" w="med" len="med"/>
+                    </a:lnB>
+                    <a:solidFill>
+                      <a:srgbClr val="EEF3F8"/>
+                    </a:solidFill>
+                  </a:tcPr>
+                </a:tc>
+                <a:tc>
+                  <a:txBody>
+                    <a:bodyPr/>
+                    <a:lstStyle/>
+                    <a:p>
+                      <a:pPr indent="0" marL="0">
+                        <a:buNone/>
+                      </a:pPr>
+                      <a:r>
+                        <a:rPr lang="en-US" sz="1150" dirty="0">
+                          <a:solidFill>
+                            <a:srgbClr val="1A2B45"/>
+                          </a:solidFill>
+                          <a:latin typeface="Calibri" pitchFamily="34" charset="0"/>
+                          <a:ea typeface="Calibri" pitchFamily="34" charset="-122"/>
+                          <a:cs typeface="Calibri" pitchFamily="34" charset="-120"/>
+                        </a:rPr>
+                        <a:t>自国の産業化は間接的</a:t>
+                      </a:r>
+                      <a:endParaRPr lang="en-US" sz="1150" dirty="0">
+                        <a:latin typeface="Calibri" charset="0"/>
+                        <a:ea typeface="Calibri" charset="0"/>
+                        <a:cs typeface="Calibri" charset="0"/>
+                      </a:endParaRPr>
+                    </a:p>
+                  </a:txBody>
+                  <a:tcPr marL="63500" marR="63500" marT="63500" marB="63500" anchor="ctr">
+                    <a:lnL w="12700" cap="flat" cmpd="sng" algn="ctr">
+                      <a:solidFill>
+                        <a:srgbClr val="D6E0EA"/>
+                      </a:solidFill>
+                      <a:prstDash val="solid"/>
+                      <a:round/>
+                      <a:headEnd type="none" w="med" len="med"/>
+                      <a:tailEnd type="none" w="med" len="med"/>
+                    </a:lnL>
+                    <a:lnR w="12700" cap="flat" cmpd="sng" algn="ctr">
+                      <a:solidFill>
+                        <a:srgbClr val="D6E0EA"/>
+                      </a:solidFill>
+                      <a:prstDash val="solid"/>
+                      <a:round/>
+                      <a:headEnd type="none" w="med" len="med"/>
+                      <a:tailEnd type="none" w="med" len="med"/>
+                    </a:lnR>
+                    <a:lnT w="12700" cap="flat" cmpd="sng" algn="ctr">
+                      <a:solidFill>
+                        <a:srgbClr val="D6E0EA"/>
+                      </a:solidFill>
+                      <a:prstDash val="solid"/>
+                      <a:round/>
+                      <a:headEnd type="none" w="med" len="med"/>
+                      <a:tailEnd type="none" w="med" len="med"/>
+                    </a:lnT>
+                    <a:lnB w="12700" cap="flat" cmpd="sng" algn="ctr">
+                      <a:solidFill>
+                        <a:srgbClr val="D6E0EA"/>
+                      </a:solidFill>
+                      <a:prstDash val="solid"/>
+                      <a:round/>
+                      <a:headEnd type="none" w="med" len="med"/>
+                      <a:tailEnd type="none" w="med" len="med"/>
+                    </a:lnB>
+                  </a:tcPr>
+                </a:tc>
+                <a:tc>
+                  <a:txBody>
+                    <a:bodyPr/>
+                    <a:lstStyle/>
+                    <a:p>
+                      <a:pPr indent="0" marL="0">
+                        <a:buNone/>
+                      </a:pPr>
+                      <a:r>
+                        <a:rPr lang="en-US" sz="1150" dirty="0">
+                          <a:solidFill>
+                            <a:srgbClr val="1A2B45"/>
+                          </a:solidFill>
+                          <a:latin typeface="Calibri" pitchFamily="34" charset="0"/>
+                          <a:ea typeface="Calibri" pitchFamily="34" charset="-122"/>
+                          <a:cs typeface="Calibri" pitchFamily="34" charset="-120"/>
+                        </a:rPr>
+                        <a:t>分散・スピード・処遇で見劣り</a:t>
+                      </a:r>
+                      <a:endParaRPr lang="en-US" sz="1150" dirty="0">
+                        <a:latin typeface="Calibri" charset="0"/>
+                        <a:ea typeface="Calibri" charset="0"/>
+                        <a:cs typeface="Calibri" charset="0"/>
+                      </a:endParaRPr>
+                    </a:p>
+                  </a:txBody>
+                  <a:tcPr marL="63500" marR="63500" marT="63500" marB="63500" anchor="ctr">
+                    <a:lnL w="12700" cap="flat" cmpd="sng" algn="ctr">
+                      <a:solidFill>
+                        <a:srgbClr val="D6E0EA"/>
+                      </a:solidFill>
+                      <a:prstDash val="solid"/>
+                      <a:round/>
+                      <a:headEnd type="none" w="med" len="med"/>
+                      <a:tailEnd type="none" w="med" len="med"/>
+                    </a:lnL>
+                    <a:lnR w="12700" cap="flat" cmpd="sng" algn="ctr">
+                      <a:solidFill>
+                        <a:srgbClr val="D6E0EA"/>
+                      </a:solidFill>
+                      <a:prstDash val="solid"/>
+                      <a:round/>
+                      <a:headEnd type="none" w="med" len="med"/>
+                      <a:tailEnd type="none" w="med" len="med"/>
+                    </a:lnR>
+                    <a:lnT w="12700" cap="flat" cmpd="sng" algn="ctr">
+                      <a:solidFill>
+                        <a:srgbClr val="D6E0EA"/>
+                      </a:solidFill>
+                      <a:prstDash val="solid"/>
+                      <a:round/>
+                      <a:headEnd type="none" w="med" len="med"/>
+                      <a:tailEnd type="none" w="med" len="med"/>
+                    </a:lnT>
+                    <a:lnB w="12700" cap="flat" cmpd="sng" algn="ctr">
+                      <a:solidFill>
+                        <a:srgbClr val="D6E0EA"/>
+                      </a:solidFill>
+                      <a:prstDash val="solid"/>
+                      <a:round/>
+                      <a:headEnd type="none" w="med" len="med"/>
+                      <a:tailEnd type="none" w="med" len="med"/>
+                    </a:lnB>
+                  </a:tcPr>
+                </a:tc>
+                <a:tc>
+                  <a:txBody>
+                    <a:bodyPr/>
+                    <a:lstStyle/>
+                    <a:p>
+                      <a:pPr indent="0" marL="0">
+                        <a:buNone/>
+                      </a:pPr>
+                      <a:r>
+                        <a:rPr lang="en-US" sz="1150" dirty="0">
+                          <a:solidFill>
+                            <a:srgbClr val="1A2B45"/>
+                          </a:solidFill>
+                          <a:latin typeface="Calibri" pitchFamily="34" charset="0"/>
+                          <a:ea typeface="Calibri" pitchFamily="34" charset="-122"/>
+                          <a:cs typeface="Calibri" pitchFamily="34" charset="-120"/>
+                        </a:rPr>
+                        <a:t>新興・巨額の国費依存</a:t>
+                      </a:r>
+                      <a:endParaRPr lang="en-US" sz="1150" dirty="0">
+                        <a:latin typeface="Calibri" charset="0"/>
+                        <a:ea typeface="Calibri" charset="0"/>
+                        <a:cs typeface="Calibri" charset="0"/>
+                      </a:endParaRPr>
+                    </a:p>
+                  </a:txBody>
+                  <a:tcPr marL="63500" marR="63500" marT="63500" marB="63500" anchor="ctr">
+                    <a:lnL w="12700" cap="flat" cmpd="sng" algn="ctr">
+                      <a:solidFill>
+                        <a:srgbClr val="D6E0EA"/>
+                      </a:solidFill>
+                      <a:prstDash val="solid"/>
+                      <a:round/>
+                      <a:headEnd type="none" w="med" len="med"/>
+                      <a:tailEnd type="none" w="med" len="med"/>
+                    </a:lnL>
+                    <a:lnR w="12700" cap="flat" cmpd="sng" algn="ctr">
+                      <a:solidFill>
+                        <a:srgbClr val="D6E0EA"/>
+                      </a:solidFill>
+                      <a:prstDash val="solid"/>
+                      <a:round/>
+                      <a:headEnd type="none" w="med" len="med"/>
+                      <a:tailEnd type="none" w="med" len="med"/>
+                    </a:lnR>
+                    <a:lnT w="12700" cap="flat" cmpd="sng" algn="ctr">
+                      <a:solidFill>
+                        <a:srgbClr val="D6E0EA"/>
+                      </a:solidFill>
+                      <a:prstDash val="solid"/>
+                      <a:round/>
+                      <a:headEnd type="none" w="med" len="med"/>
+                      <a:tailEnd type="none" w="med" len="med"/>
+                    </a:lnT>
+                    <a:lnB w="12700" cap="flat" cmpd="sng" algn="ctr">
+                      <a:solidFill>
+                        <a:srgbClr val="D6E0EA"/>
+                      </a:solidFill>
+                      <a:prstDash val="solid"/>
+                      <a:round/>
+                      <a:headEnd type="none" w="med" len="med"/>
+                      <a:tailEnd type="none" w="med" len="med"/>
+                    </a:lnB>
+                  </a:tcPr>
+                </a:tc>
+              </a:tr>
+            </a:tbl>
+          </a:graphicData>
+        </a:graphic>
+      </p:graphicFrame>
+      <p:sp>
+        <p:nvSpPr>
+          <p:cNvPr id="5" name="Text 2"/>
+          <p:cNvSpPr/>
+          <p:nvPr/>
+        </p:nvSpPr>
+        <p:spPr>
+          <a:xfrm>
+            <a:off x="457200" y="5989320"/>
+            <a:ext cx="11247120" cy="548640"/>
+          </a:xfrm>
+          <a:prstGeom prst="rect">
+            <a:avLst/>
+          </a:prstGeom>
+          <a:noFill/>
+          <a:ln/>
+        </p:spPr>
+        <p:txBody>
+          <a:bodyPr wrap="square" lIns="0" tIns="0" rIns="0" bIns="0" rtlCol="0" anchor="ctr"/>
+          <a:lstStyle/>
+          <a:p>
+            <a:pPr indent="0" marL="0">
+              <a:buNone/>
+            </a:pPr>
+            <a:r>
+              <a:rPr lang="en-US" sz="1100" i="1" dirty="0">
+                <a:solidFill>
+                  <a:srgbClr val="6B7A8F"/>
+                </a:solidFill>
+                <a:latin typeface="Calibri" pitchFamily="34" charset="0"/>
+                <a:ea typeface="Calibri" pitchFamily="34" charset="-122"/>
+                <a:cs typeface="Calibri" pitchFamily="34" charset="-120"/>
+              </a:rPr>
+              <a:t>出典整理: research/SEMICON_NATIONAL_RD_ECOSYSTEM.md（数値は概算・要確認）。日本の座組は 基礎/材料(NIMS)→共用試作(AIST/TIA)→束ね(LSTC)→量産(Rapidus) のバケツリレー。</a:t>
+            </a:r>
+            <a:endParaRPr lang="en-US" sz="1100" dirty="0"/>
+          </a:p>
+        </p:txBody>
+      </p:sp>
+      <p:sp>
+        <p:nvSpPr>
+          <p:cNvPr id="6" name="Text 3"/>
+          <p:cNvSpPr/>
+          <p:nvPr/>
+        </p:nvSpPr>
+        <p:spPr>
+          <a:xfrm>
+            <a:off x="11548872" y="6446520"/>
+            <a:ext cx="457200" cy="274320"/>
+          </a:xfrm>
+          <a:prstGeom prst="rect">
+            <a:avLst/>
+          </a:prstGeom>
+          <a:noFill/>
+          <a:ln/>
+        </p:spPr>
+        <p:txBody>
+          <a:bodyPr wrap="square" rtlCol="0" anchor="ctr"/>
+          <a:lstStyle/>
+          <a:p>
+            <a:pPr algn="r" indent="0" marL="0">
+              <a:buNone/>
+            </a:pPr>
+            <a:r>
+              <a:rPr lang="en-US" sz="1000" dirty="0">
+                <a:solidFill>
+                  <a:srgbClr val="6B7A8F"/>
+                </a:solidFill>
+                <a:latin typeface="Calibri" pitchFamily="34" charset="0"/>
+                <a:ea typeface="Calibri" pitchFamily="34" charset="-122"/>
+                <a:cs typeface="Calibri" pitchFamily="34" charset="-120"/>
+              </a:rPr>
+              <a:t>19</a:t>
+            </a:r>
+            <a:endParaRPr lang="en-US" sz="1000" dirty="0"/>
+          </a:p>
+        </p:txBody>
+      </p:sp>
+    </p:spTree>
+  </p:cSld>
+  <p:clrMapOvr>
+    <a:masterClrMapping/>
+  </p:clrMapOvr>
+</p:sld>
+</file>
+
 <file path=ppt/slides/slide2.xml><?xml version="1.0" encoding="utf-8"?>
 <p:sld xmlns:a="http://schemas.openxmlformats.org/drawingml/2006/main" xmlns:r="http://schemas.openxmlformats.org/officeDocument/2006/relationships" xmlns:p="http://schemas.openxmlformats.org/presentationml/2006/main">
   <p:cSld name="Slide 2">

</xml_diff>